<commit_message>
update and add new ppts
</commit_message>
<xml_diff>
--- a/在主愛中(崇拜版).pptx
+++ b/在主愛中(崇拜版).pptx
@@ -5,12 +5,17 @@
     <p:sldMasterId id="2147483660" r:id="rId1"/>
   </p:sldMasterIdLst>
   <p:sldIdLst>
-    <p:sldId id="256" r:id="rId2"/>
-    <p:sldId id="257" r:id="rId3"/>
-    <p:sldId id="258" r:id="rId4"/>
-    <p:sldId id="259" r:id="rId5"/>
+    <p:sldId id="391" r:id="rId2"/>
+    <p:sldId id="392" r:id="rId3"/>
+    <p:sldId id="393" r:id="rId4"/>
+    <p:sldId id="394" r:id="rId5"/>
+    <p:sldId id="395" r:id="rId6"/>
+    <p:sldId id="396" r:id="rId7"/>
+    <p:sldId id="397" r:id="rId8"/>
+    <p:sldId id="398" r:id="rId9"/>
+    <p:sldId id="399" r:id="rId10"/>
   </p:sldIdLst>
-  <p:sldSz cx="9144000" cy="6858000" type="screen4x3"/>
+  <p:sldSz cx="12192000" cy="6858000"/>
   <p:notesSz cx="6858000" cy="9144000"/>
   <p:defaultTextStyle>
     <a:defPPr>
@@ -107,6 +112,22 @@
       </a:defRPr>
     </a:lvl9pPr>
   </p:defaultTextStyle>
+  <p:extLst>
+    <p:ext uri="{EFAFB233-063F-42B5-8137-9DF3F51BA10A}">
+      <p15:sldGuideLst xmlns:p15="http://schemas.microsoft.com/office/powerpoint/2012/main">
+        <p15:guide id="1" orient="horz" pos="2160" userDrawn="1">
+          <p15:clr>
+            <a:srgbClr val="A4A3A4"/>
+          </p15:clr>
+        </p15:guide>
+        <p15:guide id="2" pos="3840" userDrawn="1">
+          <p15:clr>
+            <a:srgbClr val="A4A3A4"/>
+          </p15:clr>
+        </p15:guide>
+      </p15:sldGuideLst>
+    </p:ext>
+  </p:extLst>
 </p:presentation>
 </file>
 
@@ -139,8 +160,8 @@
         </p:nvSpPr>
         <p:spPr>
           <a:xfrm>
-            <a:off x="685800" y="2130425"/>
-            <a:ext cx="7772400" cy="1470025"/>
+            <a:off x="914400" y="2130426"/>
+            <a:ext cx="10363200" cy="1470025"/>
           </a:xfrm>
         </p:spPr>
         <p:txBody>
@@ -148,10 +169,9 @@
           <a:lstStyle/>
           <a:p>
             <a:r>
-              <a:rPr lang="zh-TW" altLang="en-US" smtClean="0"/>
+              <a:rPr lang="zh-TW" altLang="en-US"/>
               <a:t>按一下以編輯母片標題樣式</a:t>
             </a:r>
-            <a:endParaRPr lang="zh-TW" altLang="en-US"/>
           </a:p>
         </p:txBody>
       </p:sp>
@@ -167,8 +187,8 @@
         </p:nvSpPr>
         <p:spPr>
           <a:xfrm>
-            <a:off x="1371600" y="3886200"/>
-            <a:ext cx="6400800" cy="1752600"/>
+            <a:off x="1828800" y="3886200"/>
+            <a:ext cx="8534400" cy="1752600"/>
           </a:xfrm>
         </p:spPr>
         <p:txBody>
@@ -267,10 +287,9 @@
           </a:lstStyle>
           <a:p>
             <a:r>
-              <a:rPr lang="zh-TW" altLang="en-US" smtClean="0"/>
+              <a:rPr lang="zh-TW" altLang="en-US"/>
               <a:t>按一下以編輯母片副標題樣式</a:t>
             </a:r>
-            <a:endParaRPr lang="zh-TW" altLang="en-US"/>
           </a:p>
         </p:txBody>
       </p:sp>
@@ -291,7 +310,7 @@
           <a:p>
             <a:fld id="{6986F854-54BC-4F92-94E3-7610C6B222FC}" type="datetimeFigureOut">
               <a:rPr lang="zh-TW" altLang="en-US" smtClean="0"/>
-              <a:t>2018/7/29</a:t>
+              <a:t>2026/10/15</a:t>
             </a:fld>
             <a:endParaRPr lang="zh-TW" altLang="en-US"/>
           </a:p>
@@ -380,10 +399,9 @@
           <a:lstStyle/>
           <a:p>
             <a:r>
-              <a:rPr lang="zh-TW" altLang="en-US" smtClean="0"/>
+              <a:rPr lang="zh-TW" altLang="en-US"/>
               <a:t>按一下以編輯母片標題樣式</a:t>
             </a:r>
-            <a:endParaRPr lang="zh-TW" altLang="en-US"/>
           </a:p>
         </p:txBody>
       </p:sp>
@@ -404,38 +422,37 @@
           <a:p>
             <a:pPr lvl="0"/>
             <a:r>
-              <a:rPr lang="zh-TW" altLang="en-US" smtClean="0"/>
+              <a:rPr lang="zh-TW" altLang="en-US"/>
               <a:t>按一下以編輯母片文字樣式</a:t>
             </a:r>
           </a:p>
           <a:p>
             <a:pPr lvl="1"/>
             <a:r>
-              <a:rPr lang="zh-TW" altLang="en-US" smtClean="0"/>
+              <a:rPr lang="zh-TW" altLang="en-US"/>
               <a:t>第二層</a:t>
             </a:r>
           </a:p>
           <a:p>
             <a:pPr lvl="2"/>
             <a:r>
-              <a:rPr lang="zh-TW" altLang="en-US" smtClean="0"/>
+              <a:rPr lang="zh-TW" altLang="en-US"/>
               <a:t>第三層</a:t>
             </a:r>
           </a:p>
           <a:p>
             <a:pPr lvl="3"/>
             <a:r>
-              <a:rPr lang="zh-TW" altLang="en-US" smtClean="0"/>
+              <a:rPr lang="zh-TW" altLang="en-US"/>
               <a:t>第四層</a:t>
             </a:r>
           </a:p>
           <a:p>
             <a:pPr lvl="4"/>
             <a:r>
-              <a:rPr lang="zh-TW" altLang="en-US" smtClean="0"/>
+              <a:rPr lang="zh-TW" altLang="en-US"/>
               <a:t>第五層</a:t>
             </a:r>
-            <a:endParaRPr lang="zh-TW" altLang="en-US"/>
           </a:p>
         </p:txBody>
       </p:sp>
@@ -456,7 +473,7 @@
           <a:p>
             <a:fld id="{6986F854-54BC-4F92-94E3-7610C6B222FC}" type="datetimeFigureOut">
               <a:rPr lang="zh-TW" altLang="en-US" smtClean="0"/>
-              <a:t>2018/7/29</a:t>
+              <a:t>2026/10/15</a:t>
             </a:fld>
             <a:endParaRPr lang="zh-TW" altLang="en-US"/>
           </a:p>
@@ -541,8 +558,8 @@
         </p:nvSpPr>
         <p:spPr>
           <a:xfrm>
-            <a:off x="6629400" y="274638"/>
-            <a:ext cx="2057400" cy="5851525"/>
+            <a:off x="8839200" y="274639"/>
+            <a:ext cx="2743200" cy="5851525"/>
           </a:xfrm>
         </p:spPr>
         <p:txBody>
@@ -550,10 +567,9 @@
           <a:lstStyle/>
           <a:p>
             <a:r>
-              <a:rPr lang="zh-TW" altLang="en-US" smtClean="0"/>
+              <a:rPr lang="zh-TW" altLang="en-US"/>
               <a:t>按一下以編輯母片標題樣式</a:t>
             </a:r>
-            <a:endParaRPr lang="zh-TW" altLang="en-US"/>
           </a:p>
         </p:txBody>
       </p:sp>
@@ -569,8 +585,8 @@
         </p:nvSpPr>
         <p:spPr>
           <a:xfrm>
-            <a:off x="457200" y="274638"/>
-            <a:ext cx="6019800" cy="5851525"/>
+            <a:off x="609600" y="274639"/>
+            <a:ext cx="8026400" cy="5851525"/>
           </a:xfrm>
         </p:spPr>
         <p:txBody>
@@ -579,38 +595,37 @@
           <a:p>
             <a:pPr lvl="0"/>
             <a:r>
-              <a:rPr lang="zh-TW" altLang="en-US" smtClean="0"/>
+              <a:rPr lang="zh-TW" altLang="en-US"/>
               <a:t>按一下以編輯母片文字樣式</a:t>
             </a:r>
           </a:p>
           <a:p>
             <a:pPr lvl="1"/>
             <a:r>
-              <a:rPr lang="zh-TW" altLang="en-US" smtClean="0"/>
+              <a:rPr lang="zh-TW" altLang="en-US"/>
               <a:t>第二層</a:t>
             </a:r>
           </a:p>
           <a:p>
             <a:pPr lvl="2"/>
             <a:r>
-              <a:rPr lang="zh-TW" altLang="en-US" smtClean="0"/>
+              <a:rPr lang="zh-TW" altLang="en-US"/>
               <a:t>第三層</a:t>
             </a:r>
           </a:p>
           <a:p>
             <a:pPr lvl="3"/>
             <a:r>
-              <a:rPr lang="zh-TW" altLang="en-US" smtClean="0"/>
+              <a:rPr lang="zh-TW" altLang="en-US"/>
               <a:t>第四層</a:t>
             </a:r>
           </a:p>
           <a:p>
             <a:pPr lvl="4"/>
             <a:r>
-              <a:rPr lang="zh-TW" altLang="en-US" smtClean="0"/>
+              <a:rPr lang="zh-TW" altLang="en-US"/>
               <a:t>第五層</a:t>
             </a:r>
-            <a:endParaRPr lang="zh-TW" altLang="en-US"/>
           </a:p>
         </p:txBody>
       </p:sp>
@@ -631,7 +646,7 @@
           <a:p>
             <a:fld id="{6986F854-54BC-4F92-94E3-7610C6B222FC}" type="datetimeFigureOut">
               <a:rPr lang="zh-TW" altLang="en-US" smtClean="0"/>
-              <a:t>2018/7/29</a:t>
+              <a:t>2026/10/15</a:t>
             </a:fld>
             <a:endParaRPr lang="zh-TW" altLang="en-US"/>
           </a:p>
@@ -720,10 +735,9 @@
           <a:lstStyle/>
           <a:p>
             <a:r>
-              <a:rPr lang="zh-TW" altLang="en-US" smtClean="0"/>
+              <a:rPr lang="zh-TW" altLang="en-US"/>
               <a:t>按一下以編輯母片標題樣式</a:t>
             </a:r>
-            <a:endParaRPr lang="zh-TW" altLang="en-US"/>
           </a:p>
         </p:txBody>
       </p:sp>
@@ -744,38 +758,37 @@
           <a:p>
             <a:pPr lvl="0"/>
             <a:r>
-              <a:rPr lang="zh-TW" altLang="en-US" smtClean="0"/>
+              <a:rPr lang="zh-TW" altLang="en-US"/>
               <a:t>按一下以編輯母片文字樣式</a:t>
             </a:r>
           </a:p>
           <a:p>
             <a:pPr lvl="1"/>
             <a:r>
-              <a:rPr lang="zh-TW" altLang="en-US" smtClean="0"/>
+              <a:rPr lang="zh-TW" altLang="en-US"/>
               <a:t>第二層</a:t>
             </a:r>
           </a:p>
           <a:p>
             <a:pPr lvl="2"/>
             <a:r>
-              <a:rPr lang="zh-TW" altLang="en-US" smtClean="0"/>
+              <a:rPr lang="zh-TW" altLang="en-US"/>
               <a:t>第三層</a:t>
             </a:r>
           </a:p>
           <a:p>
             <a:pPr lvl="3"/>
             <a:r>
-              <a:rPr lang="zh-TW" altLang="en-US" smtClean="0"/>
+              <a:rPr lang="zh-TW" altLang="en-US"/>
               <a:t>第四層</a:t>
             </a:r>
           </a:p>
           <a:p>
             <a:pPr lvl="4"/>
             <a:r>
-              <a:rPr lang="zh-TW" altLang="en-US" smtClean="0"/>
+              <a:rPr lang="zh-TW" altLang="en-US"/>
               <a:t>第五層</a:t>
             </a:r>
-            <a:endParaRPr lang="zh-TW" altLang="en-US"/>
           </a:p>
         </p:txBody>
       </p:sp>
@@ -796,7 +809,7 @@
           <a:p>
             <a:fld id="{6986F854-54BC-4F92-94E3-7610C6B222FC}" type="datetimeFigureOut">
               <a:rPr lang="zh-TW" altLang="en-US" smtClean="0"/>
-              <a:t>2018/7/29</a:t>
+              <a:t>2026/10/15</a:t>
             </a:fld>
             <a:endParaRPr lang="zh-TW" altLang="en-US"/>
           </a:p>
@@ -881,8 +894,8 @@
         </p:nvSpPr>
         <p:spPr>
           <a:xfrm>
-            <a:off x="722313" y="4406900"/>
-            <a:ext cx="7772400" cy="1362075"/>
+            <a:off x="963084" y="4406901"/>
+            <a:ext cx="10363200" cy="1362075"/>
           </a:xfrm>
         </p:spPr>
         <p:txBody>
@@ -894,10 +907,9 @@
           </a:lstStyle>
           <a:p>
             <a:r>
-              <a:rPr lang="zh-TW" altLang="en-US" smtClean="0"/>
+              <a:rPr lang="zh-TW" altLang="en-US"/>
               <a:t>按一下以編輯母片標題樣式</a:t>
             </a:r>
-            <a:endParaRPr lang="zh-TW" altLang="en-US"/>
           </a:p>
         </p:txBody>
       </p:sp>
@@ -913,8 +925,8 @@
         </p:nvSpPr>
         <p:spPr>
           <a:xfrm>
-            <a:off x="722313" y="2906713"/>
-            <a:ext cx="7772400" cy="1500187"/>
+            <a:off x="963084" y="2906713"/>
+            <a:ext cx="10363200" cy="1500187"/>
           </a:xfrm>
         </p:spPr>
         <p:txBody>
@@ -1014,7 +1026,7 @@
           <a:p>
             <a:pPr lvl="0"/>
             <a:r>
-              <a:rPr lang="zh-TW" altLang="en-US" smtClean="0"/>
+              <a:rPr lang="zh-TW" altLang="en-US"/>
               <a:t>按一下以編輯母片文字樣式</a:t>
             </a:r>
           </a:p>
@@ -1037,7 +1049,7 @@
           <a:p>
             <a:fld id="{6986F854-54BC-4F92-94E3-7610C6B222FC}" type="datetimeFigureOut">
               <a:rPr lang="zh-TW" altLang="en-US" smtClean="0"/>
-              <a:t>2018/7/29</a:t>
+              <a:t>2026/10/15</a:t>
             </a:fld>
             <a:endParaRPr lang="zh-TW" altLang="en-US"/>
           </a:p>
@@ -1126,10 +1138,9 @@
           <a:lstStyle/>
           <a:p>
             <a:r>
-              <a:rPr lang="zh-TW" altLang="en-US" smtClean="0"/>
+              <a:rPr lang="zh-TW" altLang="en-US"/>
               <a:t>按一下以編輯母片標題樣式</a:t>
             </a:r>
-            <a:endParaRPr lang="zh-TW" altLang="en-US"/>
           </a:p>
         </p:txBody>
       </p:sp>
@@ -1145,8 +1156,8 @@
         </p:nvSpPr>
         <p:spPr>
           <a:xfrm>
-            <a:off x="457200" y="1600200"/>
-            <a:ext cx="4038600" cy="4525963"/>
+            <a:off x="609600" y="1600201"/>
+            <a:ext cx="5384800" cy="4525963"/>
           </a:xfrm>
         </p:spPr>
         <p:txBody>
@@ -1183,38 +1194,37 @@
           <a:p>
             <a:pPr lvl="0"/>
             <a:r>
-              <a:rPr lang="zh-TW" altLang="en-US" smtClean="0"/>
+              <a:rPr lang="zh-TW" altLang="en-US"/>
               <a:t>按一下以編輯母片文字樣式</a:t>
             </a:r>
           </a:p>
           <a:p>
             <a:pPr lvl="1"/>
             <a:r>
-              <a:rPr lang="zh-TW" altLang="en-US" smtClean="0"/>
+              <a:rPr lang="zh-TW" altLang="en-US"/>
               <a:t>第二層</a:t>
             </a:r>
           </a:p>
           <a:p>
             <a:pPr lvl="2"/>
             <a:r>
-              <a:rPr lang="zh-TW" altLang="en-US" smtClean="0"/>
+              <a:rPr lang="zh-TW" altLang="en-US"/>
               <a:t>第三層</a:t>
             </a:r>
           </a:p>
           <a:p>
             <a:pPr lvl="3"/>
             <a:r>
-              <a:rPr lang="zh-TW" altLang="en-US" smtClean="0"/>
+              <a:rPr lang="zh-TW" altLang="en-US"/>
               <a:t>第四層</a:t>
             </a:r>
           </a:p>
           <a:p>
             <a:pPr lvl="4"/>
             <a:r>
-              <a:rPr lang="zh-TW" altLang="en-US" smtClean="0"/>
+              <a:rPr lang="zh-TW" altLang="en-US"/>
               <a:t>第五層</a:t>
             </a:r>
-            <a:endParaRPr lang="zh-TW" altLang="en-US"/>
           </a:p>
         </p:txBody>
       </p:sp>
@@ -1230,8 +1240,8 @@
         </p:nvSpPr>
         <p:spPr>
           <a:xfrm>
-            <a:off x="4648200" y="1600200"/>
-            <a:ext cx="4038600" cy="4525963"/>
+            <a:off x="6197600" y="1600201"/>
+            <a:ext cx="5384800" cy="4525963"/>
           </a:xfrm>
         </p:spPr>
         <p:txBody>
@@ -1268,38 +1278,37 @@
           <a:p>
             <a:pPr lvl="0"/>
             <a:r>
-              <a:rPr lang="zh-TW" altLang="en-US" smtClean="0"/>
+              <a:rPr lang="zh-TW" altLang="en-US"/>
               <a:t>按一下以編輯母片文字樣式</a:t>
             </a:r>
           </a:p>
           <a:p>
             <a:pPr lvl="1"/>
             <a:r>
-              <a:rPr lang="zh-TW" altLang="en-US" smtClean="0"/>
+              <a:rPr lang="zh-TW" altLang="en-US"/>
               <a:t>第二層</a:t>
             </a:r>
           </a:p>
           <a:p>
             <a:pPr lvl="2"/>
             <a:r>
-              <a:rPr lang="zh-TW" altLang="en-US" smtClean="0"/>
+              <a:rPr lang="zh-TW" altLang="en-US"/>
               <a:t>第三層</a:t>
             </a:r>
           </a:p>
           <a:p>
             <a:pPr lvl="3"/>
             <a:r>
-              <a:rPr lang="zh-TW" altLang="en-US" smtClean="0"/>
+              <a:rPr lang="zh-TW" altLang="en-US"/>
               <a:t>第四層</a:t>
             </a:r>
           </a:p>
           <a:p>
             <a:pPr lvl="4"/>
             <a:r>
-              <a:rPr lang="zh-TW" altLang="en-US" smtClean="0"/>
+              <a:rPr lang="zh-TW" altLang="en-US"/>
               <a:t>第五層</a:t>
             </a:r>
-            <a:endParaRPr lang="zh-TW" altLang="en-US"/>
           </a:p>
         </p:txBody>
       </p:sp>
@@ -1320,7 +1329,7 @@
           <a:p>
             <a:fld id="{6986F854-54BC-4F92-94E3-7610C6B222FC}" type="datetimeFigureOut">
               <a:rPr lang="zh-TW" altLang="en-US" smtClean="0"/>
-              <a:t>2018/7/29</a:t>
+              <a:t>2026/10/15</a:t>
             </a:fld>
             <a:endParaRPr lang="zh-TW" altLang="en-US"/>
           </a:p>
@@ -1413,10 +1422,9 @@
           </a:lstStyle>
           <a:p>
             <a:r>
-              <a:rPr lang="zh-TW" altLang="en-US" smtClean="0"/>
+              <a:rPr lang="zh-TW" altLang="en-US"/>
               <a:t>按一下以編輯母片標題樣式</a:t>
             </a:r>
-            <a:endParaRPr lang="zh-TW" altLang="en-US"/>
           </a:p>
         </p:txBody>
       </p:sp>
@@ -1432,8 +1440,8 @@
         </p:nvSpPr>
         <p:spPr>
           <a:xfrm>
-            <a:off x="457200" y="1535113"/>
-            <a:ext cx="4040188" cy="639762"/>
+            <a:off x="609600" y="1535113"/>
+            <a:ext cx="5386917" cy="639762"/>
           </a:xfrm>
         </p:spPr>
         <p:txBody>
@@ -1479,7 +1487,7 @@
           <a:p>
             <a:pPr lvl="0"/>
             <a:r>
-              <a:rPr lang="zh-TW" altLang="en-US" smtClean="0"/>
+              <a:rPr lang="zh-TW" altLang="en-US"/>
               <a:t>按一下以編輯母片文字樣式</a:t>
             </a:r>
           </a:p>
@@ -1497,8 +1505,8 @@
         </p:nvSpPr>
         <p:spPr>
           <a:xfrm>
-            <a:off x="457200" y="2174875"/>
-            <a:ext cx="4040188" cy="3951288"/>
+            <a:off x="609600" y="2174875"/>
+            <a:ext cx="5386917" cy="3951288"/>
           </a:xfrm>
         </p:spPr>
         <p:txBody>
@@ -1535,38 +1543,37 @@
           <a:p>
             <a:pPr lvl="0"/>
             <a:r>
-              <a:rPr lang="zh-TW" altLang="en-US" smtClean="0"/>
+              <a:rPr lang="zh-TW" altLang="en-US"/>
               <a:t>按一下以編輯母片文字樣式</a:t>
             </a:r>
           </a:p>
           <a:p>
             <a:pPr lvl="1"/>
             <a:r>
-              <a:rPr lang="zh-TW" altLang="en-US" smtClean="0"/>
+              <a:rPr lang="zh-TW" altLang="en-US"/>
               <a:t>第二層</a:t>
             </a:r>
           </a:p>
           <a:p>
             <a:pPr lvl="2"/>
             <a:r>
-              <a:rPr lang="zh-TW" altLang="en-US" smtClean="0"/>
+              <a:rPr lang="zh-TW" altLang="en-US"/>
               <a:t>第三層</a:t>
             </a:r>
           </a:p>
           <a:p>
             <a:pPr lvl="3"/>
             <a:r>
-              <a:rPr lang="zh-TW" altLang="en-US" smtClean="0"/>
+              <a:rPr lang="zh-TW" altLang="en-US"/>
               <a:t>第四層</a:t>
             </a:r>
           </a:p>
           <a:p>
             <a:pPr lvl="4"/>
             <a:r>
-              <a:rPr lang="zh-TW" altLang="en-US" smtClean="0"/>
+              <a:rPr lang="zh-TW" altLang="en-US"/>
               <a:t>第五層</a:t>
             </a:r>
-            <a:endParaRPr lang="zh-TW" altLang="en-US"/>
           </a:p>
         </p:txBody>
       </p:sp>
@@ -1582,8 +1589,8 @@
         </p:nvSpPr>
         <p:spPr>
           <a:xfrm>
-            <a:off x="4645025" y="1535113"/>
-            <a:ext cx="4041775" cy="639762"/>
+            <a:off x="6193368" y="1535113"/>
+            <a:ext cx="5389033" cy="639762"/>
           </a:xfrm>
         </p:spPr>
         <p:txBody>
@@ -1629,7 +1636,7 @@
           <a:p>
             <a:pPr lvl="0"/>
             <a:r>
-              <a:rPr lang="zh-TW" altLang="en-US" smtClean="0"/>
+              <a:rPr lang="zh-TW" altLang="en-US"/>
               <a:t>按一下以編輯母片文字樣式</a:t>
             </a:r>
           </a:p>
@@ -1647,8 +1654,8 @@
         </p:nvSpPr>
         <p:spPr>
           <a:xfrm>
-            <a:off x="4645025" y="2174875"/>
-            <a:ext cx="4041775" cy="3951288"/>
+            <a:off x="6193368" y="2174875"/>
+            <a:ext cx="5389033" cy="3951288"/>
           </a:xfrm>
         </p:spPr>
         <p:txBody>
@@ -1685,38 +1692,37 @@
           <a:p>
             <a:pPr lvl="0"/>
             <a:r>
-              <a:rPr lang="zh-TW" altLang="en-US" smtClean="0"/>
+              <a:rPr lang="zh-TW" altLang="en-US"/>
               <a:t>按一下以編輯母片文字樣式</a:t>
             </a:r>
           </a:p>
           <a:p>
             <a:pPr lvl="1"/>
             <a:r>
-              <a:rPr lang="zh-TW" altLang="en-US" smtClean="0"/>
+              <a:rPr lang="zh-TW" altLang="en-US"/>
               <a:t>第二層</a:t>
             </a:r>
           </a:p>
           <a:p>
             <a:pPr lvl="2"/>
             <a:r>
-              <a:rPr lang="zh-TW" altLang="en-US" smtClean="0"/>
+              <a:rPr lang="zh-TW" altLang="en-US"/>
               <a:t>第三層</a:t>
             </a:r>
           </a:p>
           <a:p>
             <a:pPr lvl="3"/>
             <a:r>
-              <a:rPr lang="zh-TW" altLang="en-US" smtClean="0"/>
+              <a:rPr lang="zh-TW" altLang="en-US"/>
               <a:t>第四層</a:t>
             </a:r>
           </a:p>
           <a:p>
             <a:pPr lvl="4"/>
             <a:r>
-              <a:rPr lang="zh-TW" altLang="en-US" smtClean="0"/>
+              <a:rPr lang="zh-TW" altLang="en-US"/>
               <a:t>第五層</a:t>
             </a:r>
-            <a:endParaRPr lang="zh-TW" altLang="en-US"/>
           </a:p>
         </p:txBody>
       </p:sp>
@@ -1737,7 +1743,7 @@
           <a:p>
             <a:fld id="{6986F854-54BC-4F92-94E3-7610C6B222FC}" type="datetimeFigureOut">
               <a:rPr lang="zh-TW" altLang="en-US" smtClean="0"/>
-              <a:t>2018/7/29</a:t>
+              <a:t>2026/10/15</a:t>
             </a:fld>
             <a:endParaRPr lang="zh-TW" altLang="en-US"/>
           </a:p>
@@ -1826,10 +1832,9 @@
           <a:lstStyle/>
           <a:p>
             <a:r>
-              <a:rPr lang="zh-TW" altLang="en-US" smtClean="0"/>
+              <a:rPr lang="zh-TW" altLang="en-US"/>
               <a:t>按一下以編輯母片標題樣式</a:t>
             </a:r>
-            <a:endParaRPr lang="zh-TW" altLang="en-US"/>
           </a:p>
         </p:txBody>
       </p:sp>
@@ -1850,7 +1855,7 @@
           <a:p>
             <a:fld id="{6986F854-54BC-4F92-94E3-7610C6B222FC}" type="datetimeFigureOut">
               <a:rPr lang="zh-TW" altLang="en-US" smtClean="0"/>
-              <a:t>2018/7/29</a:t>
+              <a:t>2026/10/15</a:t>
             </a:fld>
             <a:endParaRPr lang="zh-TW" altLang="en-US"/>
           </a:p>
@@ -1940,7 +1945,7 @@
           <a:p>
             <a:fld id="{6986F854-54BC-4F92-94E3-7610C6B222FC}" type="datetimeFigureOut">
               <a:rPr lang="zh-TW" altLang="en-US" smtClean="0"/>
-              <a:t>2018/7/29</a:t>
+              <a:t>2026/10/15</a:t>
             </a:fld>
             <a:endParaRPr lang="zh-TW" altLang="en-US"/>
           </a:p>
@@ -2025,8 +2030,8 @@
         </p:nvSpPr>
         <p:spPr>
           <a:xfrm>
-            <a:off x="457200" y="273050"/>
-            <a:ext cx="3008313" cy="1162050"/>
+            <a:off x="609601" y="273050"/>
+            <a:ext cx="4011084" cy="1162050"/>
           </a:xfrm>
         </p:spPr>
         <p:txBody>
@@ -2038,10 +2043,9 @@
           </a:lstStyle>
           <a:p>
             <a:r>
-              <a:rPr lang="zh-TW" altLang="en-US" smtClean="0"/>
+              <a:rPr lang="zh-TW" altLang="en-US"/>
               <a:t>按一下以編輯母片標題樣式</a:t>
             </a:r>
-            <a:endParaRPr lang="zh-TW" altLang="en-US"/>
           </a:p>
         </p:txBody>
       </p:sp>
@@ -2057,8 +2061,8 @@
         </p:nvSpPr>
         <p:spPr>
           <a:xfrm>
-            <a:off x="3575050" y="273050"/>
-            <a:ext cx="5111750" cy="5853113"/>
+            <a:off x="4766733" y="273051"/>
+            <a:ext cx="6815667" cy="5853113"/>
           </a:xfrm>
         </p:spPr>
         <p:txBody>
@@ -2095,38 +2099,37 @@
           <a:p>
             <a:pPr lvl="0"/>
             <a:r>
-              <a:rPr lang="zh-TW" altLang="en-US" smtClean="0"/>
+              <a:rPr lang="zh-TW" altLang="en-US"/>
               <a:t>按一下以編輯母片文字樣式</a:t>
             </a:r>
           </a:p>
           <a:p>
             <a:pPr lvl="1"/>
             <a:r>
-              <a:rPr lang="zh-TW" altLang="en-US" smtClean="0"/>
+              <a:rPr lang="zh-TW" altLang="en-US"/>
               <a:t>第二層</a:t>
             </a:r>
           </a:p>
           <a:p>
             <a:pPr lvl="2"/>
             <a:r>
-              <a:rPr lang="zh-TW" altLang="en-US" smtClean="0"/>
+              <a:rPr lang="zh-TW" altLang="en-US"/>
               <a:t>第三層</a:t>
             </a:r>
           </a:p>
           <a:p>
             <a:pPr lvl="3"/>
             <a:r>
-              <a:rPr lang="zh-TW" altLang="en-US" smtClean="0"/>
+              <a:rPr lang="zh-TW" altLang="en-US"/>
               <a:t>第四層</a:t>
             </a:r>
           </a:p>
           <a:p>
             <a:pPr lvl="4"/>
             <a:r>
-              <a:rPr lang="zh-TW" altLang="en-US" smtClean="0"/>
+              <a:rPr lang="zh-TW" altLang="en-US"/>
               <a:t>第五層</a:t>
             </a:r>
-            <a:endParaRPr lang="zh-TW" altLang="en-US"/>
           </a:p>
         </p:txBody>
       </p:sp>
@@ -2142,8 +2145,8 @@
         </p:nvSpPr>
         <p:spPr>
           <a:xfrm>
-            <a:off x="457200" y="1435100"/>
-            <a:ext cx="3008313" cy="4691063"/>
+            <a:off x="609601" y="1435101"/>
+            <a:ext cx="4011084" cy="4691063"/>
           </a:xfrm>
         </p:spPr>
         <p:txBody>
@@ -2189,7 +2192,7 @@
           <a:p>
             <a:pPr lvl="0"/>
             <a:r>
-              <a:rPr lang="zh-TW" altLang="en-US" smtClean="0"/>
+              <a:rPr lang="zh-TW" altLang="en-US"/>
               <a:t>按一下以編輯母片文字樣式</a:t>
             </a:r>
           </a:p>
@@ -2212,7 +2215,7 @@
           <a:p>
             <a:fld id="{6986F854-54BC-4F92-94E3-7610C6B222FC}" type="datetimeFigureOut">
               <a:rPr lang="zh-TW" altLang="en-US" smtClean="0"/>
-              <a:t>2018/7/29</a:t>
+              <a:t>2026/10/15</a:t>
             </a:fld>
             <a:endParaRPr lang="zh-TW" altLang="en-US"/>
           </a:p>
@@ -2297,8 +2300,8 @@
         </p:nvSpPr>
         <p:spPr>
           <a:xfrm>
-            <a:off x="1792288" y="4800600"/>
-            <a:ext cx="5486400" cy="566738"/>
+            <a:off x="2389717" y="4800600"/>
+            <a:ext cx="7315200" cy="566738"/>
           </a:xfrm>
         </p:spPr>
         <p:txBody>
@@ -2310,10 +2313,9 @@
           </a:lstStyle>
           <a:p>
             <a:r>
-              <a:rPr lang="zh-TW" altLang="en-US" smtClean="0"/>
+              <a:rPr lang="zh-TW" altLang="en-US"/>
               <a:t>按一下以編輯母片標題樣式</a:t>
             </a:r>
-            <a:endParaRPr lang="zh-TW" altLang="en-US"/>
           </a:p>
         </p:txBody>
       </p:sp>
@@ -2329,8 +2331,8 @@
         </p:nvSpPr>
         <p:spPr>
           <a:xfrm>
-            <a:off x="1792288" y="612775"/>
-            <a:ext cx="5486400" cy="4114800"/>
+            <a:off x="2389717" y="612775"/>
+            <a:ext cx="7315200" cy="4114800"/>
           </a:xfrm>
         </p:spPr>
         <p:txBody>
@@ -2375,10 +2377,9 @@
           </a:lstStyle>
           <a:p>
             <a:r>
-              <a:rPr lang="zh-TW" altLang="en-US" smtClean="0"/>
+              <a:rPr lang="zh-TW" altLang="en-US"/>
               <a:t>按一下圖示以新增圖片</a:t>
             </a:r>
-            <a:endParaRPr lang="zh-TW" altLang="en-US"/>
           </a:p>
         </p:txBody>
       </p:sp>
@@ -2394,8 +2395,8 @@
         </p:nvSpPr>
         <p:spPr>
           <a:xfrm>
-            <a:off x="1792288" y="5367338"/>
-            <a:ext cx="5486400" cy="804862"/>
+            <a:off x="2389717" y="5367338"/>
+            <a:ext cx="7315200" cy="804862"/>
           </a:xfrm>
         </p:spPr>
         <p:txBody>
@@ -2441,7 +2442,7 @@
           <a:p>
             <a:pPr lvl="0"/>
             <a:r>
-              <a:rPr lang="zh-TW" altLang="en-US" smtClean="0"/>
+              <a:rPr lang="zh-TW" altLang="en-US"/>
               <a:t>按一下以編輯母片文字樣式</a:t>
             </a:r>
           </a:p>
@@ -2464,7 +2465,7 @@
           <a:p>
             <a:fld id="{6986F854-54BC-4F92-94E3-7610C6B222FC}" type="datetimeFigureOut">
               <a:rPr lang="zh-TW" altLang="en-US" smtClean="0"/>
-              <a:t>2018/7/29</a:t>
+              <a:t>2026/10/15</a:t>
             </a:fld>
             <a:endParaRPr lang="zh-TW" altLang="en-US"/>
           </a:p>
@@ -2559,8 +2560,8 @@
         </p:nvSpPr>
         <p:spPr>
           <a:xfrm>
-            <a:off x="457200" y="274638"/>
-            <a:ext cx="8229600" cy="1143000"/>
+            <a:off x="609600" y="274638"/>
+            <a:ext cx="10972800" cy="1143000"/>
           </a:xfrm>
           <a:prstGeom prst="rect">
             <a:avLst/>
@@ -2573,10 +2574,9 @@
           <a:lstStyle/>
           <a:p>
             <a:r>
-              <a:rPr lang="zh-TW" altLang="en-US" smtClean="0"/>
+              <a:rPr lang="zh-TW" altLang="en-US"/>
               <a:t>按一下以編輯母片標題樣式</a:t>
             </a:r>
-            <a:endParaRPr lang="zh-TW" altLang="en-US"/>
           </a:p>
         </p:txBody>
       </p:sp>
@@ -2592,8 +2592,8 @@
         </p:nvSpPr>
         <p:spPr>
           <a:xfrm>
-            <a:off x="457200" y="1600200"/>
-            <a:ext cx="8229600" cy="4525963"/>
+            <a:off x="609600" y="1600201"/>
+            <a:ext cx="10972800" cy="4525963"/>
           </a:xfrm>
           <a:prstGeom prst="rect">
             <a:avLst/>
@@ -2607,38 +2607,37 @@
           <a:p>
             <a:pPr lvl="0"/>
             <a:r>
-              <a:rPr lang="zh-TW" altLang="en-US" smtClean="0"/>
+              <a:rPr lang="zh-TW" altLang="en-US"/>
               <a:t>按一下以編輯母片文字樣式</a:t>
             </a:r>
           </a:p>
           <a:p>
             <a:pPr lvl="1"/>
             <a:r>
-              <a:rPr lang="zh-TW" altLang="en-US" smtClean="0"/>
+              <a:rPr lang="zh-TW" altLang="en-US"/>
               <a:t>第二層</a:t>
             </a:r>
           </a:p>
           <a:p>
             <a:pPr lvl="2"/>
             <a:r>
-              <a:rPr lang="zh-TW" altLang="en-US" smtClean="0"/>
+              <a:rPr lang="zh-TW" altLang="en-US"/>
               <a:t>第三層</a:t>
             </a:r>
           </a:p>
           <a:p>
             <a:pPr lvl="3"/>
             <a:r>
-              <a:rPr lang="zh-TW" altLang="en-US" smtClean="0"/>
+              <a:rPr lang="zh-TW" altLang="en-US"/>
               <a:t>第四層</a:t>
             </a:r>
           </a:p>
           <a:p>
             <a:pPr lvl="4"/>
             <a:r>
-              <a:rPr lang="zh-TW" altLang="en-US" smtClean="0"/>
+              <a:rPr lang="zh-TW" altLang="en-US"/>
               <a:t>第五層</a:t>
             </a:r>
-            <a:endParaRPr lang="zh-TW" altLang="en-US"/>
           </a:p>
         </p:txBody>
       </p:sp>
@@ -2654,8 +2653,8 @@
         </p:nvSpPr>
         <p:spPr>
           <a:xfrm>
-            <a:off x="457200" y="6356350"/>
-            <a:ext cx="2133600" cy="365125"/>
+            <a:off x="609600" y="6356351"/>
+            <a:ext cx="2844800" cy="365125"/>
           </a:xfrm>
           <a:prstGeom prst="rect">
             <a:avLst/>
@@ -2677,7 +2676,7 @@
           <a:p>
             <a:fld id="{6986F854-54BC-4F92-94E3-7610C6B222FC}" type="datetimeFigureOut">
               <a:rPr lang="zh-TW" altLang="en-US" smtClean="0"/>
-              <a:t>2018/7/29</a:t>
+              <a:t>2026/10/15</a:t>
             </a:fld>
             <a:endParaRPr lang="zh-TW" altLang="en-US"/>
           </a:p>
@@ -2695,8 +2694,8 @@
         </p:nvSpPr>
         <p:spPr>
           <a:xfrm>
-            <a:off x="3124200" y="6356350"/>
-            <a:ext cx="2895600" cy="365125"/>
+            <a:off x="4165600" y="6356351"/>
+            <a:ext cx="3860800" cy="365125"/>
           </a:xfrm>
           <a:prstGeom prst="rect">
             <a:avLst/>
@@ -2732,8 +2731,8 @@
         </p:nvSpPr>
         <p:spPr>
           <a:xfrm>
-            <a:off x="6553200" y="6356350"/>
-            <a:ext cx="2133600" cy="365125"/>
+            <a:off x="8737600" y="6356351"/>
+            <a:ext cx="2844800" cy="365125"/>
           </a:xfrm>
           <a:prstGeom prst="rect">
             <a:avLst/>
@@ -3035,7 +3034,13 @@
   <p:cSld>
     <p:spTree>
       <p:nvGrpSpPr>
-        <p:cNvPr id="1" name=""/>
+        <p:cNvPr id="1" name="">
+          <a:extLst>
+            <a:ext uri="{FF2B5EF4-FFF2-40B4-BE49-F238E27FC236}">
+              <a16:creationId xmlns:a16="http://schemas.microsoft.com/office/drawing/2014/main" id="{5F20F3D7-EDDF-CE30-9060-314A88E3730B}"/>
+            </a:ext>
+          </a:extLst>
+        </p:cNvPr>
         <p:cNvGrpSpPr/>
         <p:nvPr/>
       </p:nvGrpSpPr>
@@ -3049,7 +3054,13 @@
       </p:grpSpPr>
       <p:sp>
         <p:nvSpPr>
-          <p:cNvPr id="4" name="標題 3"/>
+          <p:cNvPr id="4" name="標題 3">
+            <a:extLst>
+              <a:ext uri="{FF2B5EF4-FFF2-40B4-BE49-F238E27FC236}">
+                <a16:creationId xmlns:a16="http://schemas.microsoft.com/office/drawing/2014/main" id="{CD6A41DD-B5E6-D530-EC0F-85726817D119}"/>
+              </a:ext>
+            </a:extLst>
+          </p:cNvPr>
           <p:cNvSpPr>
             <a:spLocks noGrp="1"/>
           </p:cNvSpPr>
@@ -3057,211 +3068,44 @@
             <p:ph type="title"/>
           </p:nvPr>
         </p:nvSpPr>
-        <p:spPr/>
-        <p:txBody>
-          <a:bodyPr/>
-          <a:lstStyle/>
-          <a:p>
-            <a:r>
-              <a:rPr lang="zh-CN" altLang="en-US" dirty="0" smtClean="0">
-                <a:solidFill>
-                  <a:srgbClr val="000066"/>
-                </a:solidFill>
+        <p:spPr>
+          <a:xfrm>
+            <a:off x="0" y="2660915"/>
+            <a:ext cx="12192000" cy="1143000"/>
+          </a:xfrm>
+        </p:spPr>
+        <p:txBody>
+          <a:bodyPr>
+            <a:noAutofit/>
+          </a:bodyPr>
+          <a:lstStyle/>
+          <a:p>
+            <a:r>
+              <a:rPr lang="zh-TW" altLang="en-US" sz="7200" b="1" i="1" dirty="0">
+                <a:solidFill>
+                  <a:srgbClr val="000066"/>
+                </a:solidFill>
+                <a:effectLst>
+                  <a:outerShdw blurRad="38100" dist="38100" dir="2700000" algn="tl">
+                    <a:srgbClr val="000000">
+                      <a:alpha val="43137"/>
+                    </a:srgbClr>
+                  </a:outerShdw>
+                </a:effectLst>
                 <a:latin typeface="微軟正黑體" pitchFamily="34" charset="-120"/>
                 <a:ea typeface="微軟正黑體" pitchFamily="34" charset="-120"/>
               </a:rPr>
               <a:t>在主愛中</a:t>
             </a:r>
-            <a:endParaRPr lang="zh-TW" altLang="en-US" dirty="0">
-              <a:solidFill>
-                <a:srgbClr val="000066"/>
-              </a:solidFill>
-              <a:latin typeface="微軟正黑體" pitchFamily="34" charset="-120"/>
-              <a:ea typeface="微軟正黑體" pitchFamily="34" charset="-120"/>
-            </a:endParaRPr>
-          </a:p>
-        </p:txBody>
-      </p:sp>
-      <p:sp>
-        <p:nvSpPr>
-          <p:cNvPr id="5" name="內容版面配置區 4"/>
-          <p:cNvSpPr>
-            <a:spLocks noGrp="1"/>
-          </p:cNvSpPr>
-          <p:nvPr>
-            <p:ph idx="1"/>
-          </p:nvPr>
-        </p:nvSpPr>
-        <p:spPr/>
-        <p:txBody>
-          <a:bodyPr>
-            <a:normAutofit/>
-          </a:bodyPr>
-          <a:lstStyle/>
-          <a:p>
-            <a:pPr algn="ctr">
-              <a:buNone/>
-            </a:pPr>
-            <a:r>
-              <a:rPr lang="zh-TW" altLang="en-US" sz="5400" dirty="0">
-                <a:solidFill>
-                  <a:srgbClr val="000066"/>
-                </a:solidFill>
-                <a:latin typeface="微軟正黑體" pitchFamily="34" charset="-120"/>
-                <a:ea typeface="微軟正黑體" pitchFamily="34" charset="-120"/>
-              </a:rPr>
-              <a:t>清晨</a:t>
-            </a:r>
-            <a:r>
-              <a:rPr lang="zh-TW" altLang="en-US" sz="5400" dirty="0" smtClean="0">
-                <a:solidFill>
-                  <a:srgbClr val="000066"/>
-                </a:solidFill>
-                <a:latin typeface="微軟正黑體" pitchFamily="34" charset="-120"/>
-                <a:ea typeface="微軟正黑體" pitchFamily="34" charset="-120"/>
-              </a:rPr>
-              <a:t>朝陽  天空照耀</a:t>
-            </a:r>
-            <a:endParaRPr lang="en-US" altLang="zh-TW" sz="5400" dirty="0" smtClean="0">
-              <a:solidFill>
-                <a:srgbClr val="000066"/>
-              </a:solidFill>
-              <a:latin typeface="微軟正黑體" pitchFamily="34" charset="-120"/>
-              <a:ea typeface="微軟正黑體" pitchFamily="34" charset="-120"/>
-            </a:endParaRPr>
-          </a:p>
-          <a:p>
-            <a:pPr algn="ctr">
-              <a:buNone/>
-            </a:pPr>
-            <a:r>
-              <a:rPr lang="zh-TW" altLang="en-US" sz="5400" dirty="0" smtClean="0">
-                <a:solidFill>
-                  <a:srgbClr val="000066"/>
-                </a:solidFill>
-                <a:latin typeface="微軟正黑體" pitchFamily="34" charset="-120"/>
-                <a:ea typeface="微軟正黑體" pitchFamily="34" charset="-120"/>
-              </a:rPr>
-              <a:t>彷彿</a:t>
-            </a:r>
-            <a:r>
-              <a:rPr lang="zh-TW" altLang="en-US" sz="5400" dirty="0">
-                <a:solidFill>
-                  <a:srgbClr val="000066"/>
-                </a:solidFill>
-                <a:latin typeface="微軟正黑體" pitchFamily="34" charset="-120"/>
-                <a:ea typeface="微軟正黑體" pitchFamily="34" charset="-120"/>
-              </a:rPr>
-              <a:t>對我微微</a:t>
-            </a:r>
-            <a:r>
-              <a:rPr lang="zh-TW" altLang="en-US" sz="5400" dirty="0" smtClean="0">
-                <a:solidFill>
-                  <a:srgbClr val="000066"/>
-                </a:solidFill>
-                <a:latin typeface="微軟正黑體" pitchFamily="34" charset="-120"/>
-                <a:ea typeface="微軟正黑體" pitchFamily="34" charset="-120"/>
-              </a:rPr>
-              <a:t>笑</a:t>
-            </a:r>
-            <a:endParaRPr lang="en-US" altLang="zh-TW" sz="5400" dirty="0" smtClean="0">
-              <a:solidFill>
-                <a:srgbClr val="000066"/>
-              </a:solidFill>
-              <a:latin typeface="微軟正黑體" pitchFamily="34" charset="-120"/>
-              <a:ea typeface="微軟正黑體" pitchFamily="34" charset="-120"/>
-            </a:endParaRPr>
-          </a:p>
-          <a:p>
-            <a:pPr algn="ctr">
-              <a:buNone/>
-            </a:pPr>
-            <a:r>
-              <a:rPr lang="zh-TW" altLang="en-US" sz="5400" dirty="0" smtClean="0">
-                <a:solidFill>
-                  <a:srgbClr val="000066"/>
-                </a:solidFill>
-                <a:latin typeface="微軟正黑體" pitchFamily="34" charset="-120"/>
-                <a:ea typeface="微軟正黑體" pitchFamily="34" charset="-120"/>
-              </a:rPr>
-              <a:t>陣</a:t>
-            </a:r>
-            <a:r>
-              <a:rPr lang="zh-TW" altLang="en-US" sz="5400" dirty="0">
-                <a:solidFill>
-                  <a:srgbClr val="000066"/>
-                </a:solidFill>
-                <a:latin typeface="微軟正黑體" pitchFamily="34" charset="-120"/>
-                <a:ea typeface="微軟正黑體" pitchFamily="34" charset="-120"/>
-              </a:rPr>
-              <a:t>陣</a:t>
-            </a:r>
-            <a:r>
-              <a:rPr lang="zh-TW" altLang="en-US" sz="5400" dirty="0" smtClean="0">
-                <a:solidFill>
-                  <a:srgbClr val="000066"/>
-                </a:solidFill>
-                <a:latin typeface="微軟正黑體" pitchFamily="34" charset="-120"/>
-                <a:ea typeface="微軟正黑體" pitchFamily="34" charset="-120"/>
-              </a:rPr>
-              <a:t>微風  徐徐</a:t>
-            </a:r>
-            <a:r>
-              <a:rPr lang="zh-TW" altLang="en-US" sz="5400" dirty="0">
-                <a:solidFill>
-                  <a:srgbClr val="000066"/>
-                </a:solidFill>
-                <a:latin typeface="微軟正黑體" pitchFamily="34" charset="-120"/>
-                <a:ea typeface="微軟正黑體" pitchFamily="34" charset="-120"/>
-              </a:rPr>
-              <a:t>吹</a:t>
-            </a:r>
-            <a:r>
-              <a:rPr lang="zh-TW" altLang="en-US" sz="5400" dirty="0" smtClean="0">
-                <a:solidFill>
-                  <a:srgbClr val="000066"/>
-                </a:solidFill>
-                <a:latin typeface="微軟正黑體" pitchFamily="34" charset="-120"/>
-                <a:ea typeface="微軟正黑體" pitchFamily="34" charset="-120"/>
-              </a:rPr>
-              <a:t>送</a:t>
-            </a:r>
-            <a:endParaRPr lang="en-US" altLang="zh-TW" sz="5400" dirty="0" smtClean="0">
-              <a:solidFill>
-                <a:srgbClr val="000066"/>
-              </a:solidFill>
-              <a:latin typeface="微軟正黑體" pitchFamily="34" charset="-120"/>
-              <a:ea typeface="微軟正黑體" pitchFamily="34" charset="-120"/>
-            </a:endParaRPr>
-          </a:p>
-          <a:p>
-            <a:pPr algn="ctr">
-              <a:buNone/>
-            </a:pPr>
-            <a:r>
-              <a:rPr lang="zh-TW" altLang="en-US" sz="5400" dirty="0" smtClean="0">
-                <a:solidFill>
-                  <a:srgbClr val="000066"/>
-                </a:solidFill>
-                <a:latin typeface="微軟正黑體" pitchFamily="34" charset="-120"/>
-                <a:ea typeface="微軟正黑體" pitchFamily="34" charset="-120"/>
-              </a:rPr>
-              <a:t>逍遙自在</a:t>
-            </a:r>
-            <a:r>
-              <a:rPr lang="zh-TW" altLang="en-US" sz="5400" dirty="0">
-                <a:solidFill>
-                  <a:srgbClr val="000066"/>
-                </a:solidFill>
-                <a:latin typeface="微軟正黑體" pitchFamily="34" charset="-120"/>
-                <a:ea typeface="微軟正黑體" pitchFamily="34" charset="-120"/>
-              </a:rPr>
-              <a:t>白雲飄</a:t>
-            </a:r>
           </a:p>
         </p:txBody>
       </p:sp>
     </p:spTree>
+    <p:extLst>
+      <p:ext uri="{BB962C8B-B14F-4D97-AF65-F5344CB8AC3E}">
+        <p14:creationId xmlns:p14="http://schemas.microsoft.com/office/powerpoint/2010/main" val="388492399"/>
+      </p:ext>
+    </p:extLst>
   </p:cSld>
   <p:clrMapOvr>
     <a:masterClrMapping/>
@@ -3274,7 +3118,13 @@
   <p:cSld>
     <p:spTree>
       <p:nvGrpSpPr>
-        <p:cNvPr id="1" name=""/>
+        <p:cNvPr id="1" name="">
+          <a:extLst>
+            <a:ext uri="{FF2B5EF4-FFF2-40B4-BE49-F238E27FC236}">
+              <a16:creationId xmlns:a16="http://schemas.microsoft.com/office/drawing/2014/main" id="{499F6A04-361B-D03C-72FC-83746A3861FC}"/>
+            </a:ext>
+          </a:extLst>
+        </p:cNvPr>
         <p:cNvGrpSpPr/>
         <p:nvPr/>
       </p:nvGrpSpPr>
@@ -3288,139 +3138,157 @@
       </p:grpSpPr>
       <p:sp>
         <p:nvSpPr>
-          <p:cNvPr id="4" name="標題 3"/>
-          <p:cNvSpPr>
-            <a:spLocks noGrp="1"/>
-          </p:cNvSpPr>
-          <p:nvPr>
-            <p:ph type="title"/>
-          </p:nvPr>
-        </p:nvSpPr>
-        <p:spPr/>
-        <p:txBody>
-          <a:bodyPr/>
-          <a:lstStyle/>
-          <a:p>
-            <a:r>
-              <a:rPr lang="zh-CN" altLang="en-US" dirty="0" smtClean="0">
+          <p:cNvPr id="5" name="內容版面配置區 4">
+            <a:extLst>
+              <a:ext uri="{FF2B5EF4-FFF2-40B4-BE49-F238E27FC236}">
+                <a16:creationId xmlns:a16="http://schemas.microsoft.com/office/drawing/2014/main" id="{EE77592B-EE8B-614D-4160-CDFC7BCE80DB}"/>
+              </a:ext>
+            </a:extLst>
+          </p:cNvPr>
+          <p:cNvSpPr>
+            <a:spLocks noGrp="1"/>
+          </p:cNvSpPr>
+          <p:nvPr>
+            <p:ph idx="1"/>
+          </p:nvPr>
+        </p:nvSpPr>
+        <p:spPr>
+          <a:xfrm>
+            <a:off x="0" y="2084851"/>
+            <a:ext cx="12192000" cy="2404863"/>
+          </a:xfrm>
+        </p:spPr>
+        <p:txBody>
+          <a:bodyPr anchor="ctr">
+            <a:normAutofit/>
+          </a:bodyPr>
+          <a:lstStyle/>
+          <a:p>
+            <a:pPr algn="ctr">
+              <a:buNone/>
+            </a:pPr>
+            <a:r>
+              <a:rPr lang="zh-TW" altLang="en-US" sz="6400" b="1" dirty="0">
                 <a:solidFill>
                   <a:srgbClr val="000066"/>
                 </a:solidFill>
                 <a:latin typeface="微軟正黑體" pitchFamily="34" charset="-120"/>
                 <a:ea typeface="微軟正黑體" pitchFamily="34" charset="-120"/>
               </a:rPr>
-              <a:t>在主愛中</a:t>
-            </a:r>
-            <a:endParaRPr lang="zh-TW" altLang="en-US" dirty="0">
+              <a:t>清晨朝陽</a:t>
+            </a:r>
+            <a:r>
+              <a:rPr lang="zh-CN" altLang="en-US" sz="6400" b="1" dirty="0">
+                <a:solidFill>
+                  <a:srgbClr val="000066"/>
+                </a:solidFill>
+                <a:latin typeface="微軟正黑體" pitchFamily="34" charset="-120"/>
+                <a:ea typeface="微軟正黑體" pitchFamily="34" charset="-120"/>
+              </a:rPr>
+              <a:t>　</a:t>
+            </a:r>
+            <a:r>
+              <a:rPr lang="zh-TW" altLang="en-US" sz="6400" b="1" dirty="0">
+                <a:solidFill>
+                  <a:srgbClr val="000066"/>
+                </a:solidFill>
+                <a:latin typeface="微軟正黑體" pitchFamily="34" charset="-120"/>
+                <a:ea typeface="微軟正黑體" pitchFamily="34" charset="-120"/>
+              </a:rPr>
+              <a:t>天空照耀</a:t>
+            </a:r>
+          </a:p>
+          <a:p>
+            <a:pPr algn="ctr">
+              <a:buNone/>
+            </a:pPr>
+            <a:r>
+              <a:rPr lang="zh-TW" altLang="en-US" sz="6400" b="1" dirty="0">
+                <a:solidFill>
+                  <a:srgbClr val="000066"/>
+                </a:solidFill>
+                <a:latin typeface="微軟正黑體" pitchFamily="34" charset="-120"/>
+                <a:ea typeface="微軟正黑體" pitchFamily="34" charset="-120"/>
+              </a:rPr>
+              <a:t>彷彿對我微微笑</a:t>
+            </a:r>
+          </a:p>
+        </p:txBody>
+      </p:sp>
+      <p:sp>
+        <p:nvSpPr>
+          <p:cNvPr id="3" name="TextBox 2">
+            <a:extLst>
+              <a:ext uri="{FF2B5EF4-FFF2-40B4-BE49-F238E27FC236}">
+                <a16:creationId xmlns:a16="http://schemas.microsoft.com/office/drawing/2014/main" id="{FA175DD0-F211-14DE-420F-4A50F79B6BD2}"/>
+              </a:ext>
+            </a:extLst>
+          </p:cNvPr>
+          <p:cNvSpPr txBox="1"/>
+          <p:nvPr/>
+        </p:nvSpPr>
+        <p:spPr>
+          <a:xfrm>
+            <a:off x="0" y="5157193"/>
+            <a:ext cx="12192000" cy="584775"/>
+          </a:xfrm>
+          <a:prstGeom prst="rect">
+            <a:avLst/>
+          </a:prstGeom>
+          <a:noFill/>
+        </p:spPr>
+        <p:txBody>
+          <a:bodyPr wrap="square" rtlCol="0">
+            <a:spAutoFit/>
+          </a:bodyPr>
+          <a:lstStyle/>
+          <a:p>
+            <a:pPr algn="ctr"/>
+            <a:r>
+              <a:rPr lang="en-US" sz="3200" b="1" dirty="0">
+                <a:solidFill>
+                  <a:srgbClr val="000066"/>
+                </a:solidFill>
+                <a:latin typeface="Microsoft JhengHei" panose="020B0604030504040204" pitchFamily="34" charset="-120"/>
+                <a:ea typeface="Microsoft JhengHei" panose="020B0604030504040204" pitchFamily="34" charset="-120"/>
+              </a:rPr>
+              <a:t>( </a:t>
+            </a:r>
+            <a:r>
+              <a:rPr lang="zh-CN" altLang="en-US" sz="3200" b="1" dirty="0">
+                <a:solidFill>
+                  <a:srgbClr val="000066"/>
+                </a:solidFill>
+                <a:latin typeface="Microsoft JhengHei" panose="020B0604030504040204" pitchFamily="34" charset="-120"/>
+                <a:ea typeface="Microsoft JhengHei" panose="020B0604030504040204" pitchFamily="34" charset="-120"/>
+              </a:rPr>
+              <a:t>正歌</a:t>
+            </a:r>
+            <a:r>
+              <a:rPr lang="en-US" sz="3200" b="1" dirty="0">
+                <a:solidFill>
+                  <a:srgbClr val="000066"/>
+                </a:solidFill>
+                <a:latin typeface="Microsoft JhengHei" panose="020B0604030504040204" pitchFamily="34" charset="-120"/>
+                <a:ea typeface="Microsoft JhengHei" panose="020B0604030504040204" pitchFamily="34" charset="-120"/>
+              </a:rPr>
+              <a:t> )</a:t>
+            </a:r>
+            <a:endParaRPr lang="vi-VN" sz="3200" b="1" dirty="0">
               <a:solidFill>
                 <a:srgbClr val="000066"/>
               </a:solidFill>
-              <a:latin typeface="微軟正黑體" pitchFamily="34" charset="-120"/>
-              <a:ea typeface="微軟正黑體" pitchFamily="34" charset="-120"/>
+              <a:ea typeface="Microsoft JhengHei" panose="020B0604030504040204" pitchFamily="34" charset="-120"/>
             </a:endParaRPr>
           </a:p>
         </p:txBody>
       </p:sp>
-      <p:sp>
-        <p:nvSpPr>
-          <p:cNvPr id="5" name="內容版面配置區 4"/>
-          <p:cNvSpPr>
-            <a:spLocks noGrp="1"/>
-          </p:cNvSpPr>
-          <p:nvPr>
-            <p:ph idx="1"/>
-          </p:nvPr>
-        </p:nvSpPr>
-        <p:spPr/>
-        <p:txBody>
-          <a:bodyPr>
-            <a:normAutofit/>
-          </a:bodyPr>
-          <a:lstStyle/>
-          <a:p>
-            <a:pPr algn="ctr">
-              <a:buNone/>
-            </a:pPr>
-            <a:r>
-              <a:rPr lang="zh-TW" altLang="en-US" sz="5400" dirty="0" smtClean="0">
-                <a:solidFill>
-                  <a:srgbClr val="000066"/>
-                </a:solidFill>
-                <a:latin typeface="微軟正黑體" pitchFamily="34" charset="-120"/>
-                <a:ea typeface="微軟正黑體" pitchFamily="34" charset="-120"/>
-              </a:rPr>
-              <a:t>鳥語花香  綠草如茵</a:t>
-            </a:r>
-            <a:endParaRPr lang="en-US" altLang="zh-TW" sz="5400" dirty="0" smtClean="0">
-              <a:solidFill>
-                <a:srgbClr val="000066"/>
-              </a:solidFill>
-              <a:latin typeface="微軟正黑體" pitchFamily="34" charset="-120"/>
-              <a:ea typeface="微軟正黑體" pitchFamily="34" charset="-120"/>
-            </a:endParaRPr>
-          </a:p>
-          <a:p>
-            <a:pPr algn="ctr">
-              <a:buNone/>
-            </a:pPr>
-            <a:r>
-              <a:rPr lang="zh-TW" altLang="en-US" sz="5400" dirty="0" smtClean="0">
-                <a:solidFill>
-                  <a:srgbClr val="000066"/>
-                </a:solidFill>
-                <a:latin typeface="微軟正黑體" pitchFamily="34" charset="-120"/>
-                <a:ea typeface="微軟正黑體" pitchFamily="34" charset="-120"/>
-              </a:rPr>
-              <a:t>青春時光多美好</a:t>
-            </a:r>
-            <a:endParaRPr lang="en-US" altLang="zh-TW" sz="5400" dirty="0" smtClean="0">
-              <a:solidFill>
-                <a:srgbClr val="000066"/>
-              </a:solidFill>
-              <a:latin typeface="微軟正黑體" pitchFamily="34" charset="-120"/>
-              <a:ea typeface="微軟正黑體" pitchFamily="34" charset="-120"/>
-            </a:endParaRPr>
-          </a:p>
-          <a:p>
-            <a:pPr algn="ctr">
-              <a:buNone/>
-            </a:pPr>
-            <a:r>
-              <a:rPr lang="zh-TW" altLang="en-US" sz="5400" dirty="0" smtClean="0">
-                <a:solidFill>
-                  <a:srgbClr val="000066"/>
-                </a:solidFill>
-                <a:latin typeface="微軟正黑體" pitchFamily="34" charset="-120"/>
-                <a:ea typeface="微軟正黑體" pitchFamily="34" charset="-120"/>
-              </a:rPr>
-              <a:t>盡情歌唱  盡情歡笑</a:t>
-            </a:r>
-            <a:endParaRPr lang="en-US" altLang="zh-TW" sz="5400" dirty="0" smtClean="0">
-              <a:solidFill>
-                <a:srgbClr val="000066"/>
-              </a:solidFill>
-              <a:latin typeface="微軟正黑體" pitchFamily="34" charset="-120"/>
-              <a:ea typeface="微軟正黑體" pitchFamily="34" charset="-120"/>
-            </a:endParaRPr>
-          </a:p>
-          <a:p>
-            <a:pPr algn="ctr">
-              <a:buNone/>
-            </a:pPr>
-            <a:r>
-              <a:rPr lang="zh-TW" altLang="en-US" sz="5400" dirty="0" smtClean="0">
-                <a:solidFill>
-                  <a:srgbClr val="000066"/>
-                </a:solidFill>
-                <a:latin typeface="微軟正黑體" pitchFamily="34" charset="-120"/>
-                <a:ea typeface="微軟正黑體" pitchFamily="34" charset="-120"/>
-              </a:rPr>
-              <a:t>煩惱都不見了</a:t>
-            </a:r>
-          </a:p>
-        </p:txBody>
-      </p:sp>
     </p:spTree>
+    <p:extLst>
+      <p:ext uri="{BB962C8B-B14F-4D97-AF65-F5344CB8AC3E}">
+        <p14:creationId xmlns:p14="http://schemas.microsoft.com/office/powerpoint/2010/main" val="3885075056"/>
+      </p:ext>
+    </p:extLst>
   </p:cSld>
   <p:clrMapOvr>
     <a:masterClrMapping/>
@@ -3433,7 +3301,13 @@
   <p:cSld>
     <p:spTree>
       <p:nvGrpSpPr>
-        <p:cNvPr id="1" name=""/>
+        <p:cNvPr id="1" name="">
+          <a:extLst>
+            <a:ext uri="{FF2B5EF4-FFF2-40B4-BE49-F238E27FC236}">
+              <a16:creationId xmlns:a16="http://schemas.microsoft.com/office/drawing/2014/main" id="{9FCB1610-2B4D-A47B-654F-7450D9B34E30}"/>
+            </a:ext>
+          </a:extLst>
+        </p:cNvPr>
         <p:cNvGrpSpPr/>
         <p:nvPr/>
       </p:nvGrpSpPr>
@@ -3447,139 +3321,157 @@
       </p:grpSpPr>
       <p:sp>
         <p:nvSpPr>
-          <p:cNvPr id="4" name="標題 3"/>
-          <p:cNvSpPr>
-            <a:spLocks noGrp="1"/>
-          </p:cNvSpPr>
-          <p:nvPr>
-            <p:ph type="title"/>
-          </p:nvPr>
-        </p:nvSpPr>
-        <p:spPr/>
-        <p:txBody>
-          <a:bodyPr/>
-          <a:lstStyle/>
-          <a:p>
-            <a:r>
-              <a:rPr lang="zh-CN" altLang="en-US" dirty="0" smtClean="0">
+          <p:cNvPr id="5" name="內容版面配置區 4">
+            <a:extLst>
+              <a:ext uri="{FF2B5EF4-FFF2-40B4-BE49-F238E27FC236}">
+                <a16:creationId xmlns:a16="http://schemas.microsoft.com/office/drawing/2014/main" id="{163B9305-36D2-4446-C366-06305FCF00BE}"/>
+              </a:ext>
+            </a:extLst>
+          </p:cNvPr>
+          <p:cNvSpPr>
+            <a:spLocks noGrp="1"/>
+          </p:cNvSpPr>
+          <p:nvPr>
+            <p:ph idx="1"/>
+          </p:nvPr>
+        </p:nvSpPr>
+        <p:spPr>
+          <a:xfrm>
+            <a:off x="0" y="2084851"/>
+            <a:ext cx="12192000" cy="2404863"/>
+          </a:xfrm>
+        </p:spPr>
+        <p:txBody>
+          <a:bodyPr anchor="ctr">
+            <a:normAutofit/>
+          </a:bodyPr>
+          <a:lstStyle/>
+          <a:p>
+            <a:pPr algn="ctr">
+              <a:buNone/>
+            </a:pPr>
+            <a:r>
+              <a:rPr lang="zh-TW" altLang="en-US" sz="6400" b="1" dirty="0">
                 <a:solidFill>
                   <a:srgbClr val="000066"/>
                 </a:solidFill>
                 <a:latin typeface="微軟正黑體" pitchFamily="34" charset="-120"/>
                 <a:ea typeface="微軟正黑體" pitchFamily="34" charset="-120"/>
               </a:rPr>
-              <a:t>在主愛中</a:t>
-            </a:r>
-            <a:endParaRPr lang="zh-TW" altLang="en-US" dirty="0">
+              <a:t>陣陣微風</a:t>
+            </a:r>
+            <a:r>
+              <a:rPr lang="zh-CN" altLang="en-US" sz="6400" b="1" dirty="0">
+                <a:solidFill>
+                  <a:srgbClr val="000066"/>
+                </a:solidFill>
+                <a:latin typeface="微軟正黑體" pitchFamily="34" charset="-120"/>
+                <a:ea typeface="微軟正黑體" pitchFamily="34" charset="-120"/>
+              </a:rPr>
+              <a:t>　</a:t>
+            </a:r>
+            <a:r>
+              <a:rPr lang="zh-TW" altLang="en-US" sz="6400" b="1" dirty="0">
+                <a:solidFill>
+                  <a:srgbClr val="000066"/>
+                </a:solidFill>
+                <a:latin typeface="微軟正黑體" pitchFamily="34" charset="-120"/>
+                <a:ea typeface="微軟正黑體" pitchFamily="34" charset="-120"/>
+              </a:rPr>
+              <a:t>徐徐吹送</a:t>
+            </a:r>
+          </a:p>
+          <a:p>
+            <a:pPr algn="ctr">
+              <a:buNone/>
+            </a:pPr>
+            <a:r>
+              <a:rPr lang="zh-TW" altLang="en-US" sz="6400" b="1" dirty="0">
+                <a:solidFill>
+                  <a:srgbClr val="000066"/>
+                </a:solidFill>
+                <a:latin typeface="微軟正黑體" pitchFamily="34" charset="-120"/>
+                <a:ea typeface="微軟正黑體" pitchFamily="34" charset="-120"/>
+              </a:rPr>
+              <a:t>逍遙自在白雲飄</a:t>
+            </a:r>
+          </a:p>
+        </p:txBody>
+      </p:sp>
+      <p:sp>
+        <p:nvSpPr>
+          <p:cNvPr id="3" name="TextBox 2">
+            <a:extLst>
+              <a:ext uri="{FF2B5EF4-FFF2-40B4-BE49-F238E27FC236}">
+                <a16:creationId xmlns:a16="http://schemas.microsoft.com/office/drawing/2014/main" id="{9824DD7B-1EC3-84E4-9292-5023BE748BEC}"/>
+              </a:ext>
+            </a:extLst>
+          </p:cNvPr>
+          <p:cNvSpPr txBox="1"/>
+          <p:nvPr/>
+        </p:nvSpPr>
+        <p:spPr>
+          <a:xfrm>
+            <a:off x="0" y="5157193"/>
+            <a:ext cx="12192000" cy="584775"/>
+          </a:xfrm>
+          <a:prstGeom prst="rect">
+            <a:avLst/>
+          </a:prstGeom>
+          <a:noFill/>
+        </p:spPr>
+        <p:txBody>
+          <a:bodyPr wrap="square" rtlCol="0">
+            <a:spAutoFit/>
+          </a:bodyPr>
+          <a:lstStyle/>
+          <a:p>
+            <a:pPr algn="ctr"/>
+            <a:r>
+              <a:rPr lang="en-US" sz="3200" b="1" dirty="0">
+                <a:solidFill>
+                  <a:srgbClr val="000066"/>
+                </a:solidFill>
+                <a:latin typeface="Microsoft JhengHei" panose="020B0604030504040204" pitchFamily="34" charset="-120"/>
+                <a:ea typeface="Microsoft JhengHei" panose="020B0604030504040204" pitchFamily="34" charset="-120"/>
+              </a:rPr>
+              <a:t>( </a:t>
+            </a:r>
+            <a:r>
+              <a:rPr lang="zh-CN" altLang="en-US" sz="3200" b="1" dirty="0">
+                <a:solidFill>
+                  <a:srgbClr val="000066"/>
+                </a:solidFill>
+                <a:latin typeface="Microsoft JhengHei" panose="020B0604030504040204" pitchFamily="34" charset="-120"/>
+                <a:ea typeface="Microsoft JhengHei" panose="020B0604030504040204" pitchFamily="34" charset="-120"/>
+              </a:rPr>
+              <a:t>正歌</a:t>
+            </a:r>
+            <a:r>
+              <a:rPr lang="en-US" sz="3200" b="1" dirty="0">
+                <a:solidFill>
+                  <a:srgbClr val="000066"/>
+                </a:solidFill>
+                <a:latin typeface="Microsoft JhengHei" panose="020B0604030504040204" pitchFamily="34" charset="-120"/>
+                <a:ea typeface="Microsoft JhengHei" panose="020B0604030504040204" pitchFamily="34" charset="-120"/>
+              </a:rPr>
+              <a:t> )</a:t>
+            </a:r>
+            <a:endParaRPr lang="vi-VN" sz="3200" b="1" dirty="0">
               <a:solidFill>
                 <a:srgbClr val="000066"/>
               </a:solidFill>
-              <a:latin typeface="微軟正黑體" pitchFamily="34" charset="-120"/>
-              <a:ea typeface="微軟正黑體" pitchFamily="34" charset="-120"/>
+              <a:ea typeface="Microsoft JhengHei" panose="020B0604030504040204" pitchFamily="34" charset="-120"/>
             </a:endParaRPr>
           </a:p>
         </p:txBody>
       </p:sp>
-      <p:sp>
-        <p:nvSpPr>
-          <p:cNvPr id="5" name="內容版面配置區 4"/>
-          <p:cNvSpPr>
-            <a:spLocks noGrp="1"/>
-          </p:cNvSpPr>
-          <p:nvPr>
-            <p:ph idx="1"/>
-          </p:nvPr>
-        </p:nvSpPr>
-        <p:spPr/>
-        <p:txBody>
-          <a:bodyPr>
-            <a:normAutofit/>
-          </a:bodyPr>
-          <a:lstStyle/>
-          <a:p>
-            <a:pPr algn="ctr">
-              <a:buNone/>
-            </a:pPr>
-            <a:r>
-              <a:rPr lang="zh-TW" altLang="en-US" sz="5400" dirty="0" smtClean="0">
-                <a:solidFill>
-                  <a:srgbClr val="000066"/>
-                </a:solidFill>
-                <a:latin typeface="微軟正黑體" pitchFamily="34" charset="-120"/>
-                <a:ea typeface="微軟正黑體" pitchFamily="34" charset="-120"/>
-              </a:rPr>
-              <a:t>在基督裡享受主愛</a:t>
-            </a:r>
-            <a:endParaRPr lang="en-US" altLang="zh-TW" sz="5400" dirty="0" smtClean="0">
-              <a:solidFill>
-                <a:srgbClr val="000066"/>
-              </a:solidFill>
-              <a:latin typeface="微軟正黑體" pitchFamily="34" charset="-120"/>
-              <a:ea typeface="微軟正黑體" pitchFamily="34" charset="-120"/>
-            </a:endParaRPr>
-          </a:p>
-          <a:p>
-            <a:pPr algn="ctr">
-              <a:buNone/>
-            </a:pPr>
-            <a:r>
-              <a:rPr lang="zh-TW" altLang="en-US" sz="5400" dirty="0" smtClean="0">
-                <a:solidFill>
-                  <a:srgbClr val="000066"/>
-                </a:solidFill>
-                <a:latin typeface="微軟正黑體" pitchFamily="34" charset="-120"/>
-                <a:ea typeface="微軟正黑體" pitchFamily="34" charset="-120"/>
-              </a:rPr>
-              <a:t>自由奔放樂開懷</a:t>
-            </a:r>
-            <a:endParaRPr lang="en-US" altLang="zh-TW" sz="5400" dirty="0" smtClean="0">
-              <a:solidFill>
-                <a:srgbClr val="000066"/>
-              </a:solidFill>
-              <a:latin typeface="微軟正黑體" pitchFamily="34" charset="-120"/>
-              <a:ea typeface="微軟正黑體" pitchFamily="34" charset="-120"/>
-            </a:endParaRPr>
-          </a:p>
-          <a:p>
-            <a:pPr algn="ctr">
-              <a:buNone/>
-            </a:pPr>
-            <a:r>
-              <a:rPr lang="zh-TW" altLang="en-US" sz="5400" dirty="0" smtClean="0">
-                <a:solidFill>
-                  <a:srgbClr val="000066"/>
-                </a:solidFill>
-                <a:latin typeface="微軟正黑體" pitchFamily="34" charset="-120"/>
-                <a:ea typeface="微軟正黑體" pitchFamily="34" charset="-120"/>
-              </a:rPr>
-              <a:t>世上沒有任何事物</a:t>
-            </a:r>
-            <a:endParaRPr lang="en-US" altLang="zh-TW" sz="5400" dirty="0" smtClean="0">
-              <a:solidFill>
-                <a:srgbClr val="000066"/>
-              </a:solidFill>
-              <a:latin typeface="微軟正黑體" pitchFamily="34" charset="-120"/>
-              <a:ea typeface="微軟正黑體" pitchFamily="34" charset="-120"/>
-            </a:endParaRPr>
-          </a:p>
-          <a:p>
-            <a:pPr algn="ctr">
-              <a:buNone/>
-            </a:pPr>
-            <a:r>
-              <a:rPr lang="zh-TW" altLang="en-US" sz="5400" dirty="0" smtClean="0">
-                <a:solidFill>
-                  <a:srgbClr val="000066"/>
-                </a:solidFill>
-                <a:latin typeface="微軟正黑體" pitchFamily="34" charset="-120"/>
-                <a:ea typeface="微軟正黑體" pitchFamily="34" charset="-120"/>
-              </a:rPr>
-              <a:t>能隔絕神的愛</a:t>
-            </a:r>
-          </a:p>
-        </p:txBody>
-      </p:sp>
     </p:spTree>
+    <p:extLst>
+      <p:ext uri="{BB962C8B-B14F-4D97-AF65-F5344CB8AC3E}">
+        <p14:creationId xmlns:p14="http://schemas.microsoft.com/office/powerpoint/2010/main" val="1613466140"/>
+      </p:ext>
+    </p:extLst>
   </p:cSld>
   <p:clrMapOvr>
     <a:masterClrMapping/>
@@ -3592,7 +3484,13 @@
   <p:cSld>
     <p:spTree>
       <p:nvGrpSpPr>
-        <p:cNvPr id="1" name=""/>
+        <p:cNvPr id="1" name="">
+          <a:extLst>
+            <a:ext uri="{FF2B5EF4-FFF2-40B4-BE49-F238E27FC236}">
+              <a16:creationId xmlns:a16="http://schemas.microsoft.com/office/drawing/2014/main" id="{7463CBBC-F530-BC1E-443F-D745B10A2255}"/>
+            </a:ext>
+          </a:extLst>
+        </p:cNvPr>
         <p:cNvGrpSpPr/>
         <p:nvPr/>
       </p:nvGrpSpPr>
@@ -3606,42 +3504,196 @@
       </p:grpSpPr>
       <p:sp>
         <p:nvSpPr>
-          <p:cNvPr id="4" name="標題 3"/>
-          <p:cNvSpPr>
-            <a:spLocks noGrp="1"/>
-          </p:cNvSpPr>
-          <p:nvPr>
-            <p:ph type="title"/>
-          </p:nvPr>
-        </p:nvSpPr>
-        <p:spPr/>
-        <p:txBody>
-          <a:bodyPr/>
-          <a:lstStyle/>
-          <a:p>
-            <a:r>
-              <a:rPr lang="zh-CN" altLang="en-US" dirty="0" smtClean="0">
+          <p:cNvPr id="5" name="內容版面配置區 4">
+            <a:extLst>
+              <a:ext uri="{FF2B5EF4-FFF2-40B4-BE49-F238E27FC236}">
+                <a16:creationId xmlns:a16="http://schemas.microsoft.com/office/drawing/2014/main" id="{07E7E74B-5792-E969-63B6-7DCFB581FF8C}"/>
+              </a:ext>
+            </a:extLst>
+          </p:cNvPr>
+          <p:cNvSpPr>
+            <a:spLocks noGrp="1"/>
+          </p:cNvSpPr>
+          <p:nvPr>
+            <p:ph idx="1"/>
+          </p:nvPr>
+        </p:nvSpPr>
+        <p:spPr>
+          <a:xfrm>
+            <a:off x="0" y="2084851"/>
+            <a:ext cx="12192000" cy="2404863"/>
+          </a:xfrm>
+        </p:spPr>
+        <p:txBody>
+          <a:bodyPr anchor="ctr">
+            <a:normAutofit/>
+          </a:bodyPr>
+          <a:lstStyle/>
+          <a:p>
+            <a:pPr algn="ctr">
+              <a:buNone/>
+            </a:pPr>
+            <a:r>
+              <a:rPr lang="zh-TW" altLang="en-US" sz="6400" b="1" dirty="0">
                 <a:solidFill>
                   <a:srgbClr val="000066"/>
                 </a:solidFill>
                 <a:latin typeface="微軟正黑體" pitchFamily="34" charset="-120"/>
                 <a:ea typeface="微軟正黑體" pitchFamily="34" charset="-120"/>
               </a:rPr>
-              <a:t>在主愛中</a:t>
-            </a:r>
-            <a:endParaRPr lang="zh-TW" altLang="en-US" dirty="0">
+              <a:t>鳥語花香</a:t>
+            </a:r>
+            <a:r>
+              <a:rPr lang="zh-CN" altLang="en-US" sz="6400" b="1" dirty="0">
+                <a:solidFill>
+                  <a:srgbClr val="000066"/>
+                </a:solidFill>
+                <a:latin typeface="微軟正黑體" pitchFamily="34" charset="-120"/>
+                <a:ea typeface="微軟正黑體" pitchFamily="34" charset="-120"/>
+              </a:rPr>
+              <a:t>　</a:t>
+            </a:r>
+            <a:r>
+              <a:rPr lang="zh-TW" altLang="en-US" sz="6400" b="1" dirty="0">
+                <a:solidFill>
+                  <a:srgbClr val="000066"/>
+                </a:solidFill>
+                <a:latin typeface="微軟正黑體" pitchFamily="34" charset="-120"/>
+                <a:ea typeface="微軟正黑體" pitchFamily="34" charset="-120"/>
+              </a:rPr>
+              <a:t>綠草如茵</a:t>
+            </a:r>
+          </a:p>
+          <a:p>
+            <a:pPr algn="ctr">
+              <a:buNone/>
+            </a:pPr>
+            <a:r>
+              <a:rPr lang="zh-TW" altLang="en-US" sz="6400" b="1" dirty="0">
+                <a:solidFill>
+                  <a:srgbClr val="000066"/>
+                </a:solidFill>
+                <a:latin typeface="微軟正黑體" pitchFamily="34" charset="-120"/>
+                <a:ea typeface="微軟正黑體" pitchFamily="34" charset="-120"/>
+              </a:rPr>
+              <a:t>青春時光多美好</a:t>
+            </a:r>
+          </a:p>
+        </p:txBody>
+      </p:sp>
+      <p:sp>
+        <p:nvSpPr>
+          <p:cNvPr id="3" name="TextBox 2">
+            <a:extLst>
+              <a:ext uri="{FF2B5EF4-FFF2-40B4-BE49-F238E27FC236}">
+                <a16:creationId xmlns:a16="http://schemas.microsoft.com/office/drawing/2014/main" id="{28249A35-8347-CF75-C662-4919637F54C6}"/>
+              </a:ext>
+            </a:extLst>
+          </p:cNvPr>
+          <p:cNvSpPr txBox="1"/>
+          <p:nvPr/>
+        </p:nvSpPr>
+        <p:spPr>
+          <a:xfrm>
+            <a:off x="0" y="5157193"/>
+            <a:ext cx="12192000" cy="584775"/>
+          </a:xfrm>
+          <a:prstGeom prst="rect">
+            <a:avLst/>
+          </a:prstGeom>
+          <a:noFill/>
+        </p:spPr>
+        <p:txBody>
+          <a:bodyPr wrap="square" rtlCol="0">
+            <a:spAutoFit/>
+          </a:bodyPr>
+          <a:lstStyle/>
+          <a:p>
+            <a:pPr algn="ctr"/>
+            <a:r>
+              <a:rPr lang="en-US" sz="3200" b="1" dirty="0">
+                <a:solidFill>
+                  <a:srgbClr val="000066"/>
+                </a:solidFill>
+                <a:latin typeface="Microsoft JhengHei" panose="020B0604030504040204" pitchFamily="34" charset="-120"/>
+                <a:ea typeface="Microsoft JhengHei" panose="020B0604030504040204" pitchFamily="34" charset="-120"/>
+              </a:rPr>
+              <a:t>( </a:t>
+            </a:r>
+            <a:r>
+              <a:rPr lang="zh-CN" altLang="en-US" sz="3200" b="1" dirty="0">
+                <a:solidFill>
+                  <a:srgbClr val="000066"/>
+                </a:solidFill>
+                <a:latin typeface="Microsoft JhengHei" panose="020B0604030504040204" pitchFamily="34" charset="-120"/>
+                <a:ea typeface="Microsoft JhengHei" panose="020B0604030504040204" pitchFamily="34" charset="-120"/>
+              </a:rPr>
+              <a:t>正歌</a:t>
+            </a:r>
+            <a:r>
+              <a:rPr lang="en-US" sz="3200" b="1" dirty="0">
+                <a:solidFill>
+                  <a:srgbClr val="000066"/>
+                </a:solidFill>
+                <a:latin typeface="Microsoft JhengHei" panose="020B0604030504040204" pitchFamily="34" charset="-120"/>
+                <a:ea typeface="Microsoft JhengHei" panose="020B0604030504040204" pitchFamily="34" charset="-120"/>
+              </a:rPr>
+              <a:t> )</a:t>
+            </a:r>
+            <a:endParaRPr lang="vi-VN" sz="3200" b="1" dirty="0">
               <a:solidFill>
                 <a:srgbClr val="000066"/>
               </a:solidFill>
-              <a:latin typeface="微軟正黑體" pitchFamily="34" charset="-120"/>
-              <a:ea typeface="微軟正黑體" pitchFamily="34" charset="-120"/>
+              <a:ea typeface="Microsoft JhengHei" panose="020B0604030504040204" pitchFamily="34" charset="-120"/>
             </a:endParaRPr>
           </a:p>
         </p:txBody>
       </p:sp>
-      <p:sp>
-        <p:nvSpPr>
-          <p:cNvPr id="5" name="內容版面配置區 4"/>
+    </p:spTree>
+    <p:extLst>
+      <p:ext uri="{BB962C8B-B14F-4D97-AF65-F5344CB8AC3E}">
+        <p14:creationId xmlns:p14="http://schemas.microsoft.com/office/powerpoint/2010/main" val="287734480"/>
+      </p:ext>
+    </p:extLst>
+  </p:cSld>
+  <p:clrMapOvr>
+    <a:masterClrMapping/>
+  </p:clrMapOvr>
+</p:sld>
+</file>
+
+<file path=ppt/slides/slide5.xml><?xml version="1.0" encoding="utf-8"?>
+<p:sld xmlns:a="http://schemas.openxmlformats.org/drawingml/2006/main" xmlns:r="http://schemas.openxmlformats.org/officeDocument/2006/relationships" xmlns:p="http://schemas.openxmlformats.org/presentationml/2006/main">
+  <p:cSld>
+    <p:spTree>
+      <p:nvGrpSpPr>
+        <p:cNvPr id="1" name="">
+          <a:extLst>
+            <a:ext uri="{FF2B5EF4-FFF2-40B4-BE49-F238E27FC236}">
+              <a16:creationId xmlns:a16="http://schemas.microsoft.com/office/drawing/2014/main" id="{4DF5499E-B941-F02E-BA45-61EBD6C8157A}"/>
+            </a:ext>
+          </a:extLst>
+        </p:cNvPr>
+        <p:cNvGrpSpPr/>
+        <p:nvPr/>
+      </p:nvGrpSpPr>
+      <p:grpSpPr>
+        <a:xfrm>
+          <a:off x="0" y="0"/>
+          <a:ext cx="0" cy="0"/>
+          <a:chOff x="0" y="0"/>
+          <a:chExt cx="0" cy="0"/>
+        </a:xfrm>
+      </p:grpSpPr>
+      <p:sp>
+        <p:nvSpPr>
+          <p:cNvPr id="5" name="內容版面配置區 4">
+            <a:extLst>
+              <a:ext uri="{FF2B5EF4-FFF2-40B4-BE49-F238E27FC236}">
+                <a16:creationId xmlns:a16="http://schemas.microsoft.com/office/drawing/2014/main" id="{9421F5B2-8A66-3CC1-7329-3B010A443D7D}"/>
+              </a:ext>
+            </a:extLst>
+          </p:cNvPr>
           <p:cNvSpPr>
             <a:spLocks noGrp="1"/>
           </p:cNvSpPr>
@@ -3649,9 +3701,14 @@
             <p:ph idx="1"/>
           </p:nvPr>
         </p:nvSpPr>
-        <p:spPr/>
-        <p:txBody>
-          <a:bodyPr>
+        <p:spPr>
+          <a:xfrm>
+            <a:off x="0" y="2084851"/>
+            <a:ext cx="12192000" cy="2404863"/>
+          </a:xfrm>
+        </p:spPr>
+        <p:txBody>
+          <a:bodyPr anchor="ctr">
             <a:normAutofit/>
           </a:bodyPr>
           <a:lstStyle/>
@@ -3660,85 +3717,779 @@
               <a:buNone/>
             </a:pPr>
             <a:r>
-              <a:rPr lang="zh-TW" altLang="en-US" sz="5400" dirty="0" smtClean="0">
+              <a:rPr lang="zh-TW" altLang="en-US" sz="6400" b="1" dirty="0">
                 <a:solidFill>
                   <a:srgbClr val="000066"/>
                 </a:solidFill>
                 <a:latin typeface="微軟正黑體" pitchFamily="34" charset="-120"/>
                 <a:ea typeface="微軟正黑體" pitchFamily="34" charset="-120"/>
               </a:rPr>
-              <a:t>在基督裡享受主愛</a:t>
-            </a:r>
-            <a:endParaRPr lang="en-US" altLang="zh-TW" sz="5400" dirty="0" smtClean="0">
+              <a:t>盡情歌唱</a:t>
+            </a:r>
+            <a:r>
+              <a:rPr lang="zh-CN" altLang="en-US" sz="6400" b="1" dirty="0">
+                <a:solidFill>
+                  <a:srgbClr val="000066"/>
+                </a:solidFill>
+                <a:latin typeface="微軟正黑體" pitchFamily="34" charset="-120"/>
+                <a:ea typeface="微軟正黑體" pitchFamily="34" charset="-120"/>
+              </a:rPr>
+              <a:t>　</a:t>
+            </a:r>
+            <a:r>
+              <a:rPr lang="zh-TW" altLang="en-US" sz="6400" b="1" dirty="0">
+                <a:solidFill>
+                  <a:srgbClr val="000066"/>
+                </a:solidFill>
+                <a:latin typeface="微軟正黑體" pitchFamily="34" charset="-120"/>
+                <a:ea typeface="微軟正黑體" pitchFamily="34" charset="-120"/>
+              </a:rPr>
+              <a:t>盡情歡笑</a:t>
+            </a:r>
+          </a:p>
+          <a:p>
+            <a:pPr algn="ctr">
+              <a:buNone/>
+            </a:pPr>
+            <a:r>
+              <a:rPr lang="zh-TW" altLang="en-US" sz="6400" b="1" dirty="0">
+                <a:solidFill>
+                  <a:srgbClr val="000066"/>
+                </a:solidFill>
+                <a:latin typeface="微軟正黑體" pitchFamily="34" charset="-120"/>
+                <a:ea typeface="微軟正黑體" pitchFamily="34" charset="-120"/>
+              </a:rPr>
+              <a:t>煩惱都不見了</a:t>
+            </a:r>
+          </a:p>
+        </p:txBody>
+      </p:sp>
+      <p:sp>
+        <p:nvSpPr>
+          <p:cNvPr id="3" name="TextBox 2">
+            <a:extLst>
+              <a:ext uri="{FF2B5EF4-FFF2-40B4-BE49-F238E27FC236}">
+                <a16:creationId xmlns:a16="http://schemas.microsoft.com/office/drawing/2014/main" id="{58B4D24D-188A-E9A6-0D9D-61B84140CD74}"/>
+              </a:ext>
+            </a:extLst>
+          </p:cNvPr>
+          <p:cNvSpPr txBox="1"/>
+          <p:nvPr/>
+        </p:nvSpPr>
+        <p:spPr>
+          <a:xfrm>
+            <a:off x="0" y="5157193"/>
+            <a:ext cx="12192000" cy="584775"/>
+          </a:xfrm>
+          <a:prstGeom prst="rect">
+            <a:avLst/>
+          </a:prstGeom>
+          <a:noFill/>
+        </p:spPr>
+        <p:txBody>
+          <a:bodyPr wrap="square" rtlCol="0">
+            <a:spAutoFit/>
+          </a:bodyPr>
+          <a:lstStyle/>
+          <a:p>
+            <a:pPr algn="ctr"/>
+            <a:r>
+              <a:rPr lang="en-US" sz="3200" b="1" dirty="0">
+                <a:solidFill>
+                  <a:srgbClr val="000066"/>
+                </a:solidFill>
+                <a:latin typeface="Microsoft JhengHei" panose="020B0604030504040204" pitchFamily="34" charset="-120"/>
+                <a:ea typeface="Microsoft JhengHei" panose="020B0604030504040204" pitchFamily="34" charset="-120"/>
+              </a:rPr>
+              <a:t>( </a:t>
+            </a:r>
+            <a:r>
+              <a:rPr lang="zh-CN" altLang="en-US" sz="3200" b="1" dirty="0">
+                <a:solidFill>
+                  <a:srgbClr val="000066"/>
+                </a:solidFill>
+                <a:latin typeface="Microsoft JhengHei" panose="020B0604030504040204" pitchFamily="34" charset="-120"/>
+                <a:ea typeface="Microsoft JhengHei" panose="020B0604030504040204" pitchFamily="34" charset="-120"/>
+              </a:rPr>
+              <a:t>正歌</a:t>
+            </a:r>
+            <a:r>
+              <a:rPr lang="en-US" sz="3200" b="1" dirty="0">
+                <a:solidFill>
+                  <a:srgbClr val="000066"/>
+                </a:solidFill>
+                <a:latin typeface="Microsoft JhengHei" panose="020B0604030504040204" pitchFamily="34" charset="-120"/>
+                <a:ea typeface="Microsoft JhengHei" panose="020B0604030504040204" pitchFamily="34" charset="-120"/>
+              </a:rPr>
+              <a:t> )</a:t>
+            </a:r>
+            <a:endParaRPr lang="vi-VN" sz="3200" b="1" dirty="0">
               <a:solidFill>
                 <a:srgbClr val="000066"/>
               </a:solidFill>
-              <a:latin typeface="微軟正黑體" pitchFamily="34" charset="-120"/>
-              <a:ea typeface="微軟正黑體" pitchFamily="34" charset="-120"/>
+              <a:ea typeface="Microsoft JhengHei" panose="020B0604030504040204" pitchFamily="34" charset="-120"/>
             </a:endParaRPr>
           </a:p>
+        </p:txBody>
+      </p:sp>
+    </p:spTree>
+    <p:extLst>
+      <p:ext uri="{BB962C8B-B14F-4D97-AF65-F5344CB8AC3E}">
+        <p14:creationId xmlns:p14="http://schemas.microsoft.com/office/powerpoint/2010/main" val="403017741"/>
+      </p:ext>
+    </p:extLst>
+  </p:cSld>
+  <p:clrMapOvr>
+    <a:masterClrMapping/>
+  </p:clrMapOvr>
+</p:sld>
+</file>
+
+<file path=ppt/slides/slide6.xml><?xml version="1.0" encoding="utf-8"?>
+<p:sld xmlns:a="http://schemas.openxmlformats.org/drawingml/2006/main" xmlns:r="http://schemas.openxmlformats.org/officeDocument/2006/relationships" xmlns:p="http://schemas.openxmlformats.org/presentationml/2006/main">
+  <p:cSld>
+    <p:spTree>
+      <p:nvGrpSpPr>
+        <p:cNvPr id="1" name="">
+          <a:extLst>
+            <a:ext uri="{FF2B5EF4-FFF2-40B4-BE49-F238E27FC236}">
+              <a16:creationId xmlns:a16="http://schemas.microsoft.com/office/drawing/2014/main" id="{B93D3DBD-F624-5E07-71C7-9FDDE6A670BE}"/>
+            </a:ext>
+          </a:extLst>
+        </p:cNvPr>
+        <p:cNvGrpSpPr/>
+        <p:nvPr/>
+      </p:nvGrpSpPr>
+      <p:grpSpPr>
+        <a:xfrm>
+          <a:off x="0" y="0"/>
+          <a:ext cx="0" cy="0"/>
+          <a:chOff x="0" y="0"/>
+          <a:chExt cx="0" cy="0"/>
+        </a:xfrm>
+      </p:grpSpPr>
+      <p:sp>
+        <p:nvSpPr>
+          <p:cNvPr id="5" name="內容版面配置區 4">
+            <a:extLst>
+              <a:ext uri="{FF2B5EF4-FFF2-40B4-BE49-F238E27FC236}">
+                <a16:creationId xmlns:a16="http://schemas.microsoft.com/office/drawing/2014/main" id="{639C01AC-BB43-4A39-61E8-7808AED0F3DE}"/>
+              </a:ext>
+            </a:extLst>
+          </p:cNvPr>
+          <p:cNvSpPr>
+            <a:spLocks noGrp="1"/>
+          </p:cNvSpPr>
+          <p:nvPr>
+            <p:ph idx="1"/>
+          </p:nvPr>
+        </p:nvSpPr>
+        <p:spPr>
+          <a:xfrm>
+            <a:off x="0" y="2084851"/>
+            <a:ext cx="12192000" cy="2404863"/>
+          </a:xfrm>
+        </p:spPr>
+        <p:txBody>
+          <a:bodyPr anchor="ctr">
+            <a:normAutofit/>
+          </a:bodyPr>
+          <a:lstStyle/>
           <a:p>
             <a:pPr algn="ctr">
               <a:buNone/>
             </a:pPr>
             <a:r>
-              <a:rPr lang="zh-TW" altLang="en-US" sz="5400" dirty="0" smtClean="0">
+              <a:rPr lang="zh-TW" altLang="en-US" sz="6400" b="1" dirty="0">
                 <a:solidFill>
                   <a:srgbClr val="000066"/>
                 </a:solidFill>
                 <a:latin typeface="微軟正黑體" pitchFamily="34" charset="-120"/>
                 <a:ea typeface="微軟正黑體" pitchFamily="34" charset="-120"/>
               </a:rPr>
+              <a:t>在基督裡　享受主愛</a:t>
+            </a:r>
+          </a:p>
+          <a:p>
+            <a:pPr algn="ctr">
+              <a:buNone/>
+            </a:pPr>
+            <a:r>
+              <a:rPr lang="zh-TW" altLang="en-US" sz="6400" b="1" dirty="0">
+                <a:solidFill>
+                  <a:srgbClr val="000066"/>
+                </a:solidFill>
+                <a:latin typeface="微軟正黑體" pitchFamily="34" charset="-120"/>
+                <a:ea typeface="微軟正黑體" pitchFamily="34" charset="-120"/>
+              </a:rPr>
               <a:t>自由奔放樂開懷</a:t>
             </a:r>
-            <a:endParaRPr lang="en-US" altLang="zh-TW" sz="5400" dirty="0" smtClean="0">
+          </a:p>
+        </p:txBody>
+      </p:sp>
+      <p:sp>
+        <p:nvSpPr>
+          <p:cNvPr id="3" name="TextBox 2">
+            <a:extLst>
+              <a:ext uri="{FF2B5EF4-FFF2-40B4-BE49-F238E27FC236}">
+                <a16:creationId xmlns:a16="http://schemas.microsoft.com/office/drawing/2014/main" id="{6AE1095E-5903-FCAE-8C4D-1789895ABCF1}"/>
+              </a:ext>
+            </a:extLst>
+          </p:cNvPr>
+          <p:cNvSpPr txBox="1"/>
+          <p:nvPr/>
+        </p:nvSpPr>
+        <p:spPr>
+          <a:xfrm>
+            <a:off x="0" y="5157193"/>
+            <a:ext cx="12192000" cy="584775"/>
+          </a:xfrm>
+          <a:prstGeom prst="rect">
+            <a:avLst/>
+          </a:prstGeom>
+          <a:noFill/>
+        </p:spPr>
+        <p:txBody>
+          <a:bodyPr wrap="square" rtlCol="0">
+            <a:spAutoFit/>
+          </a:bodyPr>
+          <a:lstStyle/>
+          <a:p>
+            <a:pPr algn="ctr"/>
+            <a:r>
+              <a:rPr lang="en-US" sz="3200" b="1" dirty="0">
+                <a:solidFill>
+                  <a:srgbClr val="000066"/>
+                </a:solidFill>
+                <a:latin typeface="Microsoft JhengHei" panose="020B0604030504040204" pitchFamily="34" charset="-120"/>
+                <a:ea typeface="Microsoft JhengHei" panose="020B0604030504040204" pitchFamily="34" charset="-120"/>
+              </a:rPr>
+              <a:t>( </a:t>
+            </a:r>
+            <a:r>
+              <a:rPr lang="zh-CN" altLang="en-US" sz="3200" b="1" dirty="0">
+                <a:solidFill>
+                  <a:srgbClr val="000066"/>
+                </a:solidFill>
+                <a:latin typeface="Microsoft JhengHei" panose="020B0604030504040204" pitchFamily="34" charset="-120"/>
+                <a:ea typeface="Microsoft JhengHei" panose="020B0604030504040204" pitchFamily="34" charset="-120"/>
+              </a:rPr>
+              <a:t>副歌</a:t>
+            </a:r>
+            <a:r>
+              <a:rPr lang="en-US" sz="3200" b="1" dirty="0">
+                <a:solidFill>
+                  <a:srgbClr val="000066"/>
+                </a:solidFill>
+                <a:latin typeface="Microsoft JhengHei" panose="020B0604030504040204" pitchFamily="34" charset="-120"/>
+                <a:ea typeface="Microsoft JhengHei" panose="020B0604030504040204" pitchFamily="34" charset="-120"/>
+              </a:rPr>
+              <a:t> )</a:t>
+            </a:r>
+            <a:endParaRPr lang="vi-VN" sz="3200" b="1" dirty="0">
               <a:solidFill>
                 <a:srgbClr val="000066"/>
               </a:solidFill>
-              <a:latin typeface="微軟正黑體" pitchFamily="34" charset="-120"/>
-              <a:ea typeface="微軟正黑體" pitchFamily="34" charset="-120"/>
+              <a:ea typeface="Microsoft JhengHei" panose="020B0604030504040204" pitchFamily="34" charset="-120"/>
             </a:endParaRPr>
           </a:p>
+        </p:txBody>
+      </p:sp>
+    </p:spTree>
+    <p:extLst>
+      <p:ext uri="{BB962C8B-B14F-4D97-AF65-F5344CB8AC3E}">
+        <p14:creationId xmlns:p14="http://schemas.microsoft.com/office/powerpoint/2010/main" val="514675265"/>
+      </p:ext>
+    </p:extLst>
+  </p:cSld>
+  <p:clrMapOvr>
+    <a:masterClrMapping/>
+  </p:clrMapOvr>
+</p:sld>
+</file>
+
+<file path=ppt/slides/slide7.xml><?xml version="1.0" encoding="utf-8"?>
+<p:sld xmlns:a="http://schemas.openxmlformats.org/drawingml/2006/main" xmlns:r="http://schemas.openxmlformats.org/officeDocument/2006/relationships" xmlns:p="http://schemas.openxmlformats.org/presentationml/2006/main">
+  <p:cSld>
+    <p:spTree>
+      <p:nvGrpSpPr>
+        <p:cNvPr id="1" name="">
+          <a:extLst>
+            <a:ext uri="{FF2B5EF4-FFF2-40B4-BE49-F238E27FC236}">
+              <a16:creationId xmlns:a16="http://schemas.microsoft.com/office/drawing/2014/main" id="{79A84E1F-7033-BFF1-C312-E00BD48606D4}"/>
+            </a:ext>
+          </a:extLst>
+        </p:cNvPr>
+        <p:cNvGrpSpPr/>
+        <p:nvPr/>
+      </p:nvGrpSpPr>
+      <p:grpSpPr>
+        <a:xfrm>
+          <a:off x="0" y="0"/>
+          <a:ext cx="0" cy="0"/>
+          <a:chOff x="0" y="0"/>
+          <a:chExt cx="0" cy="0"/>
+        </a:xfrm>
+      </p:grpSpPr>
+      <p:sp>
+        <p:nvSpPr>
+          <p:cNvPr id="5" name="內容版面配置區 4">
+            <a:extLst>
+              <a:ext uri="{FF2B5EF4-FFF2-40B4-BE49-F238E27FC236}">
+                <a16:creationId xmlns:a16="http://schemas.microsoft.com/office/drawing/2014/main" id="{E63D47F8-89CA-22AA-AF30-542C63FFCA82}"/>
+              </a:ext>
+            </a:extLst>
+          </p:cNvPr>
+          <p:cNvSpPr>
+            <a:spLocks noGrp="1"/>
+          </p:cNvSpPr>
+          <p:nvPr>
+            <p:ph idx="1"/>
+          </p:nvPr>
+        </p:nvSpPr>
+        <p:spPr>
+          <a:xfrm>
+            <a:off x="0" y="2084851"/>
+            <a:ext cx="12192000" cy="2404863"/>
+          </a:xfrm>
+        </p:spPr>
+        <p:txBody>
+          <a:bodyPr anchor="ctr">
+            <a:normAutofit/>
+          </a:bodyPr>
+          <a:lstStyle/>
           <a:p>
             <a:pPr algn="ctr">
               <a:buNone/>
             </a:pPr>
             <a:r>
-              <a:rPr lang="zh-TW" altLang="en-US" sz="5400" dirty="0" smtClean="0">
+              <a:rPr lang="zh-TW" altLang="en-US" sz="6400" b="1" dirty="0">
                 <a:solidFill>
                   <a:srgbClr val="000066"/>
                 </a:solidFill>
                 <a:latin typeface="微軟正黑體" pitchFamily="34" charset="-120"/>
                 <a:ea typeface="微軟正黑體" pitchFamily="34" charset="-120"/>
               </a:rPr>
-              <a:t>我要讚美我要歌頌</a:t>
-            </a:r>
-            <a:endParaRPr lang="en-US" altLang="zh-TW" sz="5400" dirty="0" smtClean="0">
+              <a:t>世上沒有任何事物</a:t>
+            </a:r>
+          </a:p>
+          <a:p>
+            <a:pPr algn="ctr">
+              <a:buNone/>
+            </a:pPr>
+            <a:r>
+              <a:rPr lang="zh-TW" altLang="en-US" sz="6400" b="1" dirty="0">
+                <a:solidFill>
+                  <a:srgbClr val="000066"/>
+                </a:solidFill>
+                <a:latin typeface="微軟正黑體" pitchFamily="34" charset="-120"/>
+                <a:ea typeface="微軟正黑體" pitchFamily="34" charset="-120"/>
+              </a:rPr>
+              <a:t>能隔絕神的愛</a:t>
+            </a:r>
+          </a:p>
+        </p:txBody>
+      </p:sp>
+      <p:sp>
+        <p:nvSpPr>
+          <p:cNvPr id="3" name="TextBox 2">
+            <a:extLst>
+              <a:ext uri="{FF2B5EF4-FFF2-40B4-BE49-F238E27FC236}">
+                <a16:creationId xmlns:a16="http://schemas.microsoft.com/office/drawing/2014/main" id="{1AC3489A-40C4-92E5-D61C-92C26501FB98}"/>
+              </a:ext>
+            </a:extLst>
+          </p:cNvPr>
+          <p:cNvSpPr txBox="1"/>
+          <p:nvPr/>
+        </p:nvSpPr>
+        <p:spPr>
+          <a:xfrm>
+            <a:off x="0" y="5157193"/>
+            <a:ext cx="12192000" cy="584775"/>
+          </a:xfrm>
+          <a:prstGeom prst="rect">
+            <a:avLst/>
+          </a:prstGeom>
+          <a:noFill/>
+        </p:spPr>
+        <p:txBody>
+          <a:bodyPr wrap="square" rtlCol="0">
+            <a:spAutoFit/>
+          </a:bodyPr>
+          <a:lstStyle/>
+          <a:p>
+            <a:pPr algn="ctr"/>
+            <a:r>
+              <a:rPr lang="en-US" sz="3200" b="1" dirty="0">
+                <a:solidFill>
+                  <a:srgbClr val="000066"/>
+                </a:solidFill>
+                <a:latin typeface="Microsoft JhengHei" panose="020B0604030504040204" pitchFamily="34" charset="-120"/>
+                <a:ea typeface="Microsoft JhengHei" panose="020B0604030504040204" pitchFamily="34" charset="-120"/>
+              </a:rPr>
+              <a:t>( </a:t>
+            </a:r>
+            <a:r>
+              <a:rPr lang="zh-CN" altLang="en-US" sz="3200" b="1" dirty="0">
+                <a:solidFill>
+                  <a:srgbClr val="000066"/>
+                </a:solidFill>
+                <a:latin typeface="Microsoft JhengHei" panose="020B0604030504040204" pitchFamily="34" charset="-120"/>
+                <a:ea typeface="Microsoft JhengHei" panose="020B0604030504040204" pitchFamily="34" charset="-120"/>
+              </a:rPr>
+              <a:t>副歌</a:t>
+            </a:r>
+            <a:r>
+              <a:rPr lang="en-US" sz="3200" b="1" dirty="0">
+                <a:solidFill>
+                  <a:srgbClr val="000066"/>
+                </a:solidFill>
+                <a:latin typeface="Microsoft JhengHei" panose="020B0604030504040204" pitchFamily="34" charset="-120"/>
+                <a:ea typeface="Microsoft JhengHei" panose="020B0604030504040204" pitchFamily="34" charset="-120"/>
+              </a:rPr>
+              <a:t> )</a:t>
+            </a:r>
+            <a:endParaRPr lang="vi-VN" sz="3200" b="1" dirty="0">
               <a:solidFill>
                 <a:srgbClr val="000066"/>
               </a:solidFill>
-              <a:latin typeface="微軟正黑體" pitchFamily="34" charset="-120"/>
-              <a:ea typeface="微軟正黑體" pitchFamily="34" charset="-120"/>
+              <a:ea typeface="Microsoft JhengHei" panose="020B0604030504040204" pitchFamily="34" charset="-120"/>
             </a:endParaRPr>
           </a:p>
+        </p:txBody>
+      </p:sp>
+    </p:spTree>
+    <p:extLst>
+      <p:ext uri="{BB962C8B-B14F-4D97-AF65-F5344CB8AC3E}">
+        <p14:creationId xmlns:p14="http://schemas.microsoft.com/office/powerpoint/2010/main" val="1496617489"/>
+      </p:ext>
+    </p:extLst>
+  </p:cSld>
+  <p:clrMapOvr>
+    <a:masterClrMapping/>
+  </p:clrMapOvr>
+</p:sld>
+</file>
+
+<file path=ppt/slides/slide8.xml><?xml version="1.0" encoding="utf-8"?>
+<p:sld xmlns:a="http://schemas.openxmlformats.org/drawingml/2006/main" xmlns:r="http://schemas.openxmlformats.org/officeDocument/2006/relationships" xmlns:p="http://schemas.openxmlformats.org/presentationml/2006/main">
+  <p:cSld>
+    <p:spTree>
+      <p:nvGrpSpPr>
+        <p:cNvPr id="1" name="">
+          <a:extLst>
+            <a:ext uri="{FF2B5EF4-FFF2-40B4-BE49-F238E27FC236}">
+              <a16:creationId xmlns:a16="http://schemas.microsoft.com/office/drawing/2014/main" id="{D3713B94-9DDA-C0F5-9ACA-B5C8C7B51268}"/>
+            </a:ext>
+          </a:extLst>
+        </p:cNvPr>
+        <p:cNvGrpSpPr/>
+        <p:nvPr/>
+      </p:nvGrpSpPr>
+      <p:grpSpPr>
+        <a:xfrm>
+          <a:off x="0" y="0"/>
+          <a:ext cx="0" cy="0"/>
+          <a:chOff x="0" y="0"/>
+          <a:chExt cx="0" cy="0"/>
+        </a:xfrm>
+      </p:grpSpPr>
+      <p:sp>
+        <p:nvSpPr>
+          <p:cNvPr id="5" name="內容版面配置區 4">
+            <a:extLst>
+              <a:ext uri="{FF2B5EF4-FFF2-40B4-BE49-F238E27FC236}">
+                <a16:creationId xmlns:a16="http://schemas.microsoft.com/office/drawing/2014/main" id="{B445E55C-D5A8-BCEA-D07D-5EB9097CB7B9}"/>
+              </a:ext>
+            </a:extLst>
+          </p:cNvPr>
+          <p:cNvSpPr>
+            <a:spLocks noGrp="1"/>
+          </p:cNvSpPr>
+          <p:nvPr>
+            <p:ph idx="1"/>
+          </p:nvPr>
+        </p:nvSpPr>
+        <p:spPr>
+          <a:xfrm>
+            <a:off x="0" y="2084851"/>
+            <a:ext cx="12192000" cy="2404863"/>
+          </a:xfrm>
+        </p:spPr>
+        <p:txBody>
+          <a:bodyPr anchor="ctr">
+            <a:normAutofit/>
+          </a:bodyPr>
+          <a:lstStyle/>
           <a:p>
             <a:pPr algn="ctr">
               <a:buNone/>
             </a:pPr>
             <a:r>
-              <a:rPr lang="zh-TW" altLang="en-US" sz="5400" dirty="0" smtClean="0">
+              <a:rPr lang="zh-TW" altLang="en-US" sz="6400" b="1" dirty="0">
                 <a:solidFill>
                   <a:srgbClr val="000066"/>
                 </a:solidFill>
                 <a:latin typeface="微軟正黑體" pitchFamily="34" charset="-120"/>
                 <a:ea typeface="微軟正黑體" pitchFamily="34" charset="-120"/>
               </a:rPr>
+              <a:t>在基督裡　享受主愛</a:t>
+            </a:r>
+          </a:p>
+          <a:p>
+            <a:pPr algn="ctr">
+              <a:buNone/>
+            </a:pPr>
+            <a:r>
+              <a:rPr lang="zh-TW" altLang="en-US" sz="6400" b="1" dirty="0">
+                <a:solidFill>
+                  <a:srgbClr val="000066"/>
+                </a:solidFill>
+                <a:latin typeface="微軟正黑體" pitchFamily="34" charset="-120"/>
+                <a:ea typeface="微軟正黑體" pitchFamily="34" charset="-120"/>
+              </a:rPr>
+              <a:t>自由奔放樂開懷</a:t>
+            </a:r>
+          </a:p>
+        </p:txBody>
+      </p:sp>
+      <p:sp>
+        <p:nvSpPr>
+          <p:cNvPr id="3" name="TextBox 2">
+            <a:extLst>
+              <a:ext uri="{FF2B5EF4-FFF2-40B4-BE49-F238E27FC236}">
+                <a16:creationId xmlns:a16="http://schemas.microsoft.com/office/drawing/2014/main" id="{12592381-A0DE-B933-F987-F54F8A4DAD63}"/>
+              </a:ext>
+            </a:extLst>
+          </p:cNvPr>
+          <p:cNvSpPr txBox="1"/>
+          <p:nvPr/>
+        </p:nvSpPr>
+        <p:spPr>
+          <a:xfrm>
+            <a:off x="0" y="5157193"/>
+            <a:ext cx="12192000" cy="584775"/>
+          </a:xfrm>
+          <a:prstGeom prst="rect">
+            <a:avLst/>
+          </a:prstGeom>
+          <a:noFill/>
+        </p:spPr>
+        <p:txBody>
+          <a:bodyPr wrap="square" rtlCol="0">
+            <a:spAutoFit/>
+          </a:bodyPr>
+          <a:lstStyle/>
+          <a:p>
+            <a:pPr algn="ctr"/>
+            <a:r>
+              <a:rPr lang="en-US" sz="3200" b="1" dirty="0">
+                <a:solidFill>
+                  <a:srgbClr val="000066"/>
+                </a:solidFill>
+                <a:latin typeface="Microsoft JhengHei" panose="020B0604030504040204" pitchFamily="34" charset="-120"/>
+                <a:ea typeface="Microsoft JhengHei" panose="020B0604030504040204" pitchFamily="34" charset="-120"/>
+              </a:rPr>
+              <a:t>( </a:t>
+            </a:r>
+            <a:r>
+              <a:rPr lang="zh-CN" altLang="en-US" sz="3200" b="1" dirty="0">
+                <a:solidFill>
+                  <a:srgbClr val="000066"/>
+                </a:solidFill>
+                <a:latin typeface="Microsoft JhengHei" panose="020B0604030504040204" pitchFamily="34" charset="-120"/>
+                <a:ea typeface="Microsoft JhengHei" panose="020B0604030504040204" pitchFamily="34" charset="-120"/>
+              </a:rPr>
+              <a:t>副歌</a:t>
+            </a:r>
+            <a:r>
+              <a:rPr lang="en-US" sz="3200" b="1" dirty="0">
+                <a:solidFill>
+                  <a:srgbClr val="000066"/>
+                </a:solidFill>
+                <a:latin typeface="Microsoft JhengHei" panose="020B0604030504040204" pitchFamily="34" charset="-120"/>
+                <a:ea typeface="Microsoft JhengHei" panose="020B0604030504040204" pitchFamily="34" charset="-120"/>
+              </a:rPr>
+              <a:t> )</a:t>
+            </a:r>
+            <a:endParaRPr lang="vi-VN" sz="3200" b="1" dirty="0">
+              <a:solidFill>
+                <a:srgbClr val="000066"/>
+              </a:solidFill>
+              <a:ea typeface="Microsoft JhengHei" panose="020B0604030504040204" pitchFamily="34" charset="-120"/>
+            </a:endParaRPr>
+          </a:p>
+        </p:txBody>
+      </p:sp>
+    </p:spTree>
+    <p:extLst>
+      <p:ext uri="{BB962C8B-B14F-4D97-AF65-F5344CB8AC3E}">
+        <p14:creationId xmlns:p14="http://schemas.microsoft.com/office/powerpoint/2010/main" val="3413582862"/>
+      </p:ext>
+    </p:extLst>
+  </p:cSld>
+  <p:clrMapOvr>
+    <a:masterClrMapping/>
+  </p:clrMapOvr>
+</p:sld>
+</file>
+
+<file path=ppt/slides/slide9.xml><?xml version="1.0" encoding="utf-8"?>
+<p:sld xmlns:a="http://schemas.openxmlformats.org/drawingml/2006/main" xmlns:r="http://schemas.openxmlformats.org/officeDocument/2006/relationships" xmlns:p="http://schemas.openxmlformats.org/presentationml/2006/main">
+  <p:cSld>
+    <p:spTree>
+      <p:nvGrpSpPr>
+        <p:cNvPr id="1" name="">
+          <a:extLst>
+            <a:ext uri="{FF2B5EF4-FFF2-40B4-BE49-F238E27FC236}">
+              <a16:creationId xmlns:a16="http://schemas.microsoft.com/office/drawing/2014/main" id="{2F9EF80C-4323-B4E9-4C35-77CD99EBDC5D}"/>
+            </a:ext>
+          </a:extLst>
+        </p:cNvPr>
+        <p:cNvGrpSpPr/>
+        <p:nvPr/>
+      </p:nvGrpSpPr>
+      <p:grpSpPr>
+        <a:xfrm>
+          <a:off x="0" y="0"/>
+          <a:ext cx="0" cy="0"/>
+          <a:chOff x="0" y="0"/>
+          <a:chExt cx="0" cy="0"/>
+        </a:xfrm>
+      </p:grpSpPr>
+      <p:sp>
+        <p:nvSpPr>
+          <p:cNvPr id="5" name="內容版面配置區 4">
+            <a:extLst>
+              <a:ext uri="{FF2B5EF4-FFF2-40B4-BE49-F238E27FC236}">
+                <a16:creationId xmlns:a16="http://schemas.microsoft.com/office/drawing/2014/main" id="{84156721-157D-5793-5B2A-BCB48D2EB0CB}"/>
+              </a:ext>
+            </a:extLst>
+          </p:cNvPr>
+          <p:cNvSpPr>
+            <a:spLocks noGrp="1"/>
+          </p:cNvSpPr>
+          <p:nvPr>
+            <p:ph idx="1"/>
+          </p:nvPr>
+        </p:nvSpPr>
+        <p:spPr>
+          <a:xfrm>
+            <a:off x="0" y="2084851"/>
+            <a:ext cx="12192000" cy="2404863"/>
+          </a:xfrm>
+        </p:spPr>
+        <p:txBody>
+          <a:bodyPr anchor="ctr">
+            <a:normAutofit/>
+          </a:bodyPr>
+          <a:lstStyle/>
+          <a:p>
+            <a:pPr algn="ctr">
+              <a:buNone/>
+            </a:pPr>
+            <a:r>
+              <a:rPr lang="zh-TW" altLang="en-US" sz="6400" b="1" dirty="0">
+                <a:solidFill>
+                  <a:srgbClr val="000066"/>
+                </a:solidFill>
+                <a:latin typeface="微軟正黑體" pitchFamily="34" charset="-120"/>
+                <a:ea typeface="微軟正黑體" pitchFamily="34" charset="-120"/>
+              </a:rPr>
+              <a:t>我要讚美　我要歌頌</a:t>
+            </a:r>
+          </a:p>
+          <a:p>
+            <a:pPr algn="ctr">
+              <a:buNone/>
+            </a:pPr>
+            <a:r>
+              <a:rPr lang="zh-TW" altLang="en-US" sz="6400" b="1" dirty="0">
+                <a:solidFill>
+                  <a:srgbClr val="000066"/>
+                </a:solidFill>
+                <a:latin typeface="微軟正黑體" pitchFamily="34" charset="-120"/>
+                <a:ea typeface="微軟正黑體" pitchFamily="34" charset="-120"/>
+              </a:rPr>
               <a:t>造物主的奇妙愛</a:t>
             </a:r>
           </a:p>
         </p:txBody>
       </p:sp>
+      <p:sp>
+        <p:nvSpPr>
+          <p:cNvPr id="3" name="TextBox 2">
+            <a:extLst>
+              <a:ext uri="{FF2B5EF4-FFF2-40B4-BE49-F238E27FC236}">
+                <a16:creationId xmlns:a16="http://schemas.microsoft.com/office/drawing/2014/main" id="{736E0070-264B-50F2-DBEC-9ADF8CA25F0B}"/>
+              </a:ext>
+            </a:extLst>
+          </p:cNvPr>
+          <p:cNvSpPr txBox="1"/>
+          <p:nvPr/>
+        </p:nvSpPr>
+        <p:spPr>
+          <a:xfrm>
+            <a:off x="0" y="5157193"/>
+            <a:ext cx="12192000" cy="584775"/>
+          </a:xfrm>
+          <a:prstGeom prst="rect">
+            <a:avLst/>
+          </a:prstGeom>
+          <a:noFill/>
+        </p:spPr>
+        <p:txBody>
+          <a:bodyPr wrap="square" rtlCol="0">
+            <a:spAutoFit/>
+          </a:bodyPr>
+          <a:lstStyle/>
+          <a:p>
+            <a:pPr algn="ctr"/>
+            <a:r>
+              <a:rPr lang="en-US" sz="3200" b="1" dirty="0">
+                <a:solidFill>
+                  <a:srgbClr val="000066"/>
+                </a:solidFill>
+                <a:latin typeface="Microsoft JhengHei" panose="020B0604030504040204" pitchFamily="34" charset="-120"/>
+                <a:ea typeface="Microsoft JhengHei" panose="020B0604030504040204" pitchFamily="34" charset="-120"/>
+              </a:rPr>
+              <a:t>( </a:t>
+            </a:r>
+            <a:r>
+              <a:rPr lang="zh-CN" altLang="en-US" sz="3200" b="1" dirty="0">
+                <a:solidFill>
+                  <a:srgbClr val="000066"/>
+                </a:solidFill>
+                <a:latin typeface="Microsoft JhengHei" panose="020B0604030504040204" pitchFamily="34" charset="-120"/>
+                <a:ea typeface="Microsoft JhengHei" panose="020B0604030504040204" pitchFamily="34" charset="-120"/>
+              </a:rPr>
+              <a:t>副歌</a:t>
+            </a:r>
+            <a:r>
+              <a:rPr lang="en-US" sz="3200" b="1" dirty="0">
+                <a:solidFill>
+                  <a:srgbClr val="000066"/>
+                </a:solidFill>
+                <a:latin typeface="Microsoft JhengHei" panose="020B0604030504040204" pitchFamily="34" charset="-120"/>
+                <a:ea typeface="Microsoft JhengHei" panose="020B0604030504040204" pitchFamily="34" charset="-120"/>
+              </a:rPr>
+              <a:t> )</a:t>
+            </a:r>
+            <a:endParaRPr lang="vi-VN" sz="3200" b="1" dirty="0">
+              <a:solidFill>
+                <a:srgbClr val="000066"/>
+              </a:solidFill>
+              <a:ea typeface="Microsoft JhengHei" panose="020B0604030504040204" pitchFamily="34" charset="-120"/>
+            </a:endParaRPr>
+          </a:p>
+        </p:txBody>
+      </p:sp>
     </p:spTree>
+    <p:extLst>
+      <p:ext uri="{BB962C8B-B14F-4D97-AF65-F5344CB8AC3E}">
+        <p14:creationId xmlns:p14="http://schemas.microsoft.com/office/powerpoint/2010/main" val="232023337"/>
+      </p:ext>
+    </p:extLst>
   </p:cSld>
   <p:clrMapOvr>
     <a:masterClrMapping/>

</xml_diff>